<commit_message>
Update presentation to current results; fix stale SHAP/permutation figures
Presentation: refreshed all stale numbers and embedded figures to the current
pipeline run, added a regression-to-band concept-diagram slide and an
unsupervised-segmentation + recommender slide, renumbered footers, removed em
dashes. Regenerated fig_perm_importance (windows top, QWK-scored) and
fig_shap_summary (regressor beeswarm) which were stale legacy plots, and
re-embedded them in both the deck and the report (Figures 9 and 10).
</commit_message>
<xml_diff>
--- a/presentation/COM6003_Oxford_Presentation.pptx
+++ b/presentation/COM6003_Oxford_Presentation.pptx
@@ -13,8 +13,10 @@
     <p:sldId id="261" r:id="rId12"/>
     <p:sldId id="262" r:id="rId13"/>
     <p:sldId id="263" r:id="rId14"/>
+    <p:sldId id="269" r:id="rId20"/>
     <p:sldId id="264" r:id="rId15"/>
     <p:sldId id="265" r:id="rId16"/>
+    <p:sldId id="268" r:id="rId19"/>
     <p:sldId id="266" r:id="rId17"/>
     <p:sldId id="267" r:id="rId18"/>
   </p:sldIdLst>
@@ -3320,7 +3322,7 @@
                 </a:solidFill>
                 <a:latin typeface="Calibri"/>
               </a:rPr>
-              <a:t>COM6003  •  Buckinghamshire New University  •  2025–26</a:t>
+              <a:t>COM6003  •  Buckinghamshire New University  •  2025-26</a:t>
             </a:r>
           </a:p>
         </p:txBody>
@@ -3355,7 +3357,7 @@
                 </a:solidFill>
                 <a:latin typeface="Calibri"/>
               </a:rPr>
-              <a:t>Author: Parsec</a:t>
+              <a:t>Author: Muhammad Omer Hussain (22509495)</a:t>
             </a:r>
           </a:p>
         </p:txBody>
@@ -3451,7 +3453,7 @@
                 </a:solidFill>
                 <a:latin typeface="Calibri"/>
               </a:rPr>
-              <a:t>SHAP-driven insights</a:t>
+              <a:t>Champion: SapStratifiedRegressor hybrid</a:t>
             </a:r>
           </a:p>
         </p:txBody>
@@ -3486,14 +3488,474 @@
                 </a:solidFill>
                 <a:latin typeface="Calibri"/>
               </a:rPr>
-              <a:t>Windows, construction age, and main fuel dominate by permutation importance</a:t>
+              <a:t>Regression on SAP score + SAP-cohort specialist; evaluated once on inspections from 2023+. Multi-seed: 0.7714 ± 0.0019 across seeds 42/123/2026.</a:t>
+            </a:r>
+          </a:p>
+        </p:txBody>
+      </p:sp>
+      <p:sp>
+        <p:nvSpPr>
+          <p:cNvPr id="5" name="Rounded Rectangle 4"/>
+          <p:cNvSpPr/>
+          <p:nvPr/>
+        </p:nvSpPr>
+        <p:spPr>
+          <a:xfrm>
+            <a:off x="640080" y="1554480"/>
+            <a:ext cx="2606040" cy="1097280"/>
+          </a:xfrm>
+          <a:prstGeom prst="roundRect">
+            <a:avLst/>
+          </a:prstGeom>
+          <a:solidFill>
+            <a:srgbClr val="F5F7FB"/>
+          </a:solidFill>
+          <a:ln>
+            <a:solidFill>
+              <a:srgbClr val="CADCFC"/>
+            </a:solidFill>
+          </a:ln>
+        </p:spPr>
+        <p:style>
+          <a:lnRef idx="1">
+            <a:schemeClr val="accent1"/>
+          </a:lnRef>
+          <a:fillRef idx="3">
+            <a:schemeClr val="accent1"/>
+          </a:fillRef>
+          <a:effectRef idx="2">
+            <a:schemeClr val="accent1"/>
+          </a:effectRef>
+          <a:fontRef idx="minor">
+            <a:schemeClr val="lt1"/>
+          </a:fontRef>
+        </p:style>
+        <p:txBody>
+          <a:bodyPr rtlCol="0" anchor="ctr"/>
+          <a:lstStyle/>
+          <a:p>
+            <a:pPr algn="ctr"/>
+          </a:p>
+        </p:txBody>
+      </p:sp>
+      <p:sp>
+        <p:nvSpPr>
+          <p:cNvPr id="6" name="TextBox 5"/>
+          <p:cNvSpPr txBox="1"/>
+          <p:nvPr/>
+        </p:nvSpPr>
+        <p:spPr>
+          <a:xfrm>
+            <a:off x="731520" y="1627632"/>
+            <a:ext cx="2423160" cy="457200"/>
+          </a:xfrm>
+          <a:prstGeom prst="rect">
+            <a:avLst/>
+          </a:prstGeom>
+          <a:noFill/>
+        </p:spPr>
+        <p:txBody>
+          <a:bodyPr wrap="square" lIns="45720" rIns="45720" tIns="18288" bIns="18288">
+            <a:spAutoFit/>
+          </a:bodyPr>
+          <a:lstStyle/>
+          <a:p>
+            <a:pPr algn="l"/>
+            <a:r>
+              <a:rPr sz="2800" b="1" i="0">
+                <a:solidFill>
+                  <a:srgbClr val="1E2761"/>
+                </a:solidFill>
+                <a:latin typeface="Calibri"/>
+              </a:rPr>
+              <a:t>0.7696</a:t>
+            </a:r>
+          </a:p>
+        </p:txBody>
+      </p:sp>
+      <p:sp>
+        <p:nvSpPr>
+          <p:cNvPr id="7" name="TextBox 6"/>
+          <p:cNvSpPr txBox="1"/>
+          <p:nvPr/>
+        </p:nvSpPr>
+        <p:spPr>
+          <a:xfrm>
+            <a:off x="731520" y="2194560"/>
+            <a:ext cx="2423160" cy="365760"/>
+          </a:xfrm>
+          <a:prstGeom prst="rect">
+            <a:avLst/>
+          </a:prstGeom>
+          <a:noFill/>
+        </p:spPr>
+        <p:txBody>
+          <a:bodyPr wrap="square" lIns="45720" rIns="45720" tIns="18288" bIns="18288">
+            <a:spAutoFit/>
+          </a:bodyPr>
+          <a:lstStyle/>
+          <a:p>
+            <a:pPr algn="l"/>
+            <a:r>
+              <a:rPr sz="1100" b="0" i="0">
+                <a:solidFill>
+                  <a:srgbClr val="4B556B"/>
+                </a:solidFill>
+                <a:latin typeface="Calibri"/>
+              </a:rPr>
+              <a:t>Quadratic Weighted Kappa</a:t>
+            </a:r>
+          </a:p>
+        </p:txBody>
+      </p:sp>
+      <p:sp>
+        <p:nvSpPr>
+          <p:cNvPr id="8" name="Rounded Rectangle 7"/>
+          <p:cNvSpPr/>
+          <p:nvPr/>
+        </p:nvSpPr>
+        <p:spPr>
+          <a:xfrm>
+            <a:off x="3429000" y="1554480"/>
+            <a:ext cx="2606040" cy="1097280"/>
+          </a:xfrm>
+          <a:prstGeom prst="roundRect">
+            <a:avLst/>
+          </a:prstGeom>
+          <a:solidFill>
+            <a:srgbClr val="F5F7FB"/>
+          </a:solidFill>
+          <a:ln>
+            <a:solidFill>
+              <a:srgbClr val="CADCFC"/>
+            </a:solidFill>
+          </a:ln>
+        </p:spPr>
+        <p:style>
+          <a:lnRef idx="1">
+            <a:schemeClr val="accent1"/>
+          </a:lnRef>
+          <a:fillRef idx="3">
+            <a:schemeClr val="accent1"/>
+          </a:fillRef>
+          <a:effectRef idx="2">
+            <a:schemeClr val="accent1"/>
+          </a:effectRef>
+          <a:fontRef idx="minor">
+            <a:schemeClr val="lt1"/>
+          </a:fontRef>
+        </p:style>
+        <p:txBody>
+          <a:bodyPr rtlCol="0" anchor="ctr"/>
+          <a:lstStyle/>
+          <a:p>
+            <a:pPr algn="ctr"/>
+          </a:p>
+        </p:txBody>
+      </p:sp>
+      <p:sp>
+        <p:nvSpPr>
+          <p:cNvPr id="9" name="TextBox 8"/>
+          <p:cNvSpPr txBox="1"/>
+          <p:nvPr/>
+        </p:nvSpPr>
+        <p:spPr>
+          <a:xfrm>
+            <a:off x="3520440" y="1627632"/>
+            <a:ext cx="2423160" cy="457200"/>
+          </a:xfrm>
+          <a:prstGeom prst="rect">
+            <a:avLst/>
+          </a:prstGeom>
+          <a:noFill/>
+        </p:spPr>
+        <p:txBody>
+          <a:bodyPr wrap="square" lIns="45720" rIns="45720" tIns="18288" bIns="18288">
+            <a:spAutoFit/>
+          </a:bodyPr>
+          <a:lstStyle/>
+          <a:p>
+            <a:pPr algn="l"/>
+            <a:r>
+              <a:rPr sz="2800" b="1" i="0">
+                <a:solidFill>
+                  <a:srgbClr val="1E2761"/>
+                </a:solidFill>
+                <a:latin typeface="Calibri"/>
+              </a:rPr>
+              <a:t>0.584</a:t>
+            </a:r>
+          </a:p>
+        </p:txBody>
+      </p:sp>
+      <p:sp>
+        <p:nvSpPr>
+          <p:cNvPr id="10" name="TextBox 9"/>
+          <p:cNvSpPr txBox="1"/>
+          <p:nvPr/>
+        </p:nvSpPr>
+        <p:spPr>
+          <a:xfrm>
+            <a:off x="3520440" y="2194560"/>
+            <a:ext cx="2423160" cy="365760"/>
+          </a:xfrm>
+          <a:prstGeom prst="rect">
+            <a:avLst/>
+          </a:prstGeom>
+          <a:noFill/>
+        </p:spPr>
+        <p:txBody>
+          <a:bodyPr wrap="square" lIns="45720" rIns="45720" tIns="18288" bIns="18288">
+            <a:spAutoFit/>
+          </a:bodyPr>
+          <a:lstStyle/>
+          <a:p>
+            <a:pPr algn="l"/>
+            <a:r>
+              <a:rPr sz="1100" b="0" i="0">
+                <a:solidFill>
+                  <a:srgbClr val="4B556B"/>
+                </a:solidFill>
+                <a:latin typeface="Calibri"/>
+              </a:rPr>
+              <a:t>Balanced accuracy</a:t>
+            </a:r>
+          </a:p>
+        </p:txBody>
+      </p:sp>
+      <p:sp>
+        <p:nvSpPr>
+          <p:cNvPr id="11" name="Rounded Rectangle 10"/>
+          <p:cNvSpPr/>
+          <p:nvPr/>
+        </p:nvSpPr>
+        <p:spPr>
+          <a:xfrm>
+            <a:off x="6217920" y="1554480"/>
+            <a:ext cx="2606040" cy="1097280"/>
+          </a:xfrm>
+          <a:prstGeom prst="roundRect">
+            <a:avLst/>
+          </a:prstGeom>
+          <a:solidFill>
+            <a:srgbClr val="F5F7FB"/>
+          </a:solidFill>
+          <a:ln>
+            <a:solidFill>
+              <a:srgbClr val="CADCFC"/>
+            </a:solidFill>
+          </a:ln>
+        </p:spPr>
+        <p:style>
+          <a:lnRef idx="1">
+            <a:schemeClr val="accent1"/>
+          </a:lnRef>
+          <a:fillRef idx="3">
+            <a:schemeClr val="accent1"/>
+          </a:fillRef>
+          <a:effectRef idx="2">
+            <a:schemeClr val="accent1"/>
+          </a:effectRef>
+          <a:fontRef idx="minor">
+            <a:schemeClr val="lt1"/>
+          </a:fontRef>
+        </p:style>
+        <p:txBody>
+          <a:bodyPr rtlCol="0" anchor="ctr"/>
+          <a:lstStyle/>
+          <a:p>
+            <a:pPr algn="ctr"/>
+          </a:p>
+        </p:txBody>
+      </p:sp>
+      <p:sp>
+        <p:nvSpPr>
+          <p:cNvPr id="12" name="TextBox 11"/>
+          <p:cNvSpPr txBox="1"/>
+          <p:nvPr/>
+        </p:nvSpPr>
+        <p:spPr>
+          <a:xfrm>
+            <a:off x="6309360" y="1627632"/>
+            <a:ext cx="2423160" cy="457200"/>
+          </a:xfrm>
+          <a:prstGeom prst="rect">
+            <a:avLst/>
+          </a:prstGeom>
+          <a:noFill/>
+        </p:spPr>
+        <p:txBody>
+          <a:bodyPr wrap="square" lIns="45720" rIns="45720" tIns="18288" bIns="18288">
+            <a:spAutoFit/>
+          </a:bodyPr>
+          <a:lstStyle/>
+          <a:p>
+            <a:pPr algn="l"/>
+            <a:r>
+              <a:rPr sz="2800" b="1" i="0">
+                <a:solidFill>
+                  <a:srgbClr val="1E2761"/>
+                </a:solidFill>
+                <a:latin typeface="Calibri"/>
+              </a:rPr>
+              <a:t>0.550</a:t>
+            </a:r>
+          </a:p>
+        </p:txBody>
+      </p:sp>
+      <p:sp>
+        <p:nvSpPr>
+          <p:cNvPr id="13" name="TextBox 12"/>
+          <p:cNvSpPr txBox="1"/>
+          <p:nvPr/>
+        </p:nvSpPr>
+        <p:spPr>
+          <a:xfrm>
+            <a:off x="6309360" y="2194560"/>
+            <a:ext cx="2423160" cy="365760"/>
+          </a:xfrm>
+          <a:prstGeom prst="rect">
+            <a:avLst/>
+          </a:prstGeom>
+          <a:noFill/>
+        </p:spPr>
+        <p:txBody>
+          <a:bodyPr wrap="square" lIns="45720" rIns="45720" tIns="18288" bIns="18288">
+            <a:spAutoFit/>
+          </a:bodyPr>
+          <a:lstStyle/>
+          <a:p>
+            <a:pPr algn="l"/>
+            <a:r>
+              <a:rPr sz="1100" b="0" i="0">
+                <a:solidFill>
+                  <a:srgbClr val="4B556B"/>
+                </a:solidFill>
+                <a:latin typeface="Calibri"/>
+              </a:rPr>
+              <a:t>Macro-F1</a:t>
+            </a:r>
+          </a:p>
+        </p:txBody>
+      </p:sp>
+      <p:sp>
+        <p:nvSpPr>
+          <p:cNvPr id="14" name="Rounded Rectangle 13"/>
+          <p:cNvSpPr/>
+          <p:nvPr/>
+        </p:nvSpPr>
+        <p:spPr>
+          <a:xfrm>
+            <a:off x="9006839" y="1554480"/>
+            <a:ext cx="2606040" cy="1097280"/>
+          </a:xfrm>
+          <a:prstGeom prst="roundRect">
+            <a:avLst/>
+          </a:prstGeom>
+          <a:solidFill>
+            <a:srgbClr val="F5F7FB"/>
+          </a:solidFill>
+          <a:ln>
+            <a:solidFill>
+              <a:srgbClr val="CADCFC"/>
+            </a:solidFill>
+          </a:ln>
+        </p:spPr>
+        <p:style>
+          <a:lnRef idx="1">
+            <a:schemeClr val="accent1"/>
+          </a:lnRef>
+          <a:fillRef idx="3">
+            <a:schemeClr val="accent1"/>
+          </a:fillRef>
+          <a:effectRef idx="2">
+            <a:schemeClr val="accent1"/>
+          </a:effectRef>
+          <a:fontRef idx="minor">
+            <a:schemeClr val="lt1"/>
+          </a:fontRef>
+        </p:style>
+        <p:txBody>
+          <a:bodyPr rtlCol="0" anchor="ctr"/>
+          <a:lstStyle/>
+          <a:p>
+            <a:pPr algn="ctr"/>
+          </a:p>
+        </p:txBody>
+      </p:sp>
+      <p:sp>
+        <p:nvSpPr>
+          <p:cNvPr id="15" name="TextBox 14"/>
+          <p:cNvSpPr txBox="1"/>
+          <p:nvPr/>
+        </p:nvSpPr>
+        <p:spPr>
+          <a:xfrm>
+            <a:off x="9098279" y="1627632"/>
+            <a:ext cx="2423160" cy="457200"/>
+          </a:xfrm>
+          <a:prstGeom prst="rect">
+            <a:avLst/>
+          </a:prstGeom>
+          <a:noFill/>
+        </p:spPr>
+        <p:txBody>
+          <a:bodyPr wrap="square" lIns="45720" rIns="45720" tIns="18288" bIns="18288">
+            <a:spAutoFit/>
+          </a:bodyPr>
+          <a:lstStyle/>
+          <a:p>
+            <a:pPr algn="l"/>
+            <a:r>
+              <a:rPr sz="2800" b="1" i="0">
+                <a:solidFill>
+                  <a:srgbClr val="1E2761"/>
+                </a:solidFill>
+                <a:latin typeface="Calibri"/>
+              </a:rPr>
+              <a:t>4.05</a:t>
+            </a:r>
+          </a:p>
+        </p:txBody>
+      </p:sp>
+      <p:sp>
+        <p:nvSpPr>
+          <p:cNvPr id="16" name="TextBox 15"/>
+          <p:cNvSpPr txBox="1"/>
+          <p:nvPr/>
+        </p:nvSpPr>
+        <p:spPr>
+          <a:xfrm>
+            <a:off x="9098279" y="2194560"/>
+            <a:ext cx="2423160" cy="365760"/>
+          </a:xfrm>
+          <a:prstGeom prst="rect">
+            <a:avLst/>
+          </a:prstGeom>
+          <a:noFill/>
+        </p:spPr>
+        <p:txBody>
+          <a:bodyPr wrap="square" lIns="45720" rIns="45720" tIns="18288" bIns="18288">
+            <a:spAutoFit/>
+          </a:bodyPr>
+          <a:lstStyle/>
+          <a:p>
+            <a:pPr algn="l"/>
+            <a:r>
+              <a:rPr sz="1100" b="0" i="0">
+                <a:solidFill>
+                  <a:srgbClr val="4B556B"/>
+                </a:solidFill>
+                <a:latin typeface="Calibri"/>
+              </a:rPr>
+              <a:t>SAP MAE (vs ~5-pt assessor noise floor) | 97.7% within 15 SAP pts (ONS DSC national: 93%)</a:t>
             </a:r>
           </a:p>
         </p:txBody>
       </p:sp>
       <p:pic>
         <p:nvPicPr>
-          <p:cNvPr id="5" name="Picture 4" descr="fig_shap_summary.png"/>
+          <p:cNvPr id="17" name="Picture 16" descr="fig_confusion.png"/>
           <p:cNvPicPr>
             <a:picLocks noChangeAspect="1"/>
           </p:cNvPicPr>
@@ -3507,120 +3969,41 @@
         </p:blipFill>
         <p:spPr>
           <a:xfrm>
-            <a:off x="548640" y="1554480"/>
-            <a:ext cx="6858000" cy="4846320"/>
+            <a:off x="1323833" y="2788920"/>
+            <a:ext cx="4118894" cy="3657600"/>
           </a:xfrm>
           <a:prstGeom prst="rect">
             <a:avLst/>
           </a:prstGeom>
         </p:spPr>
       </p:pic>
-      <p:sp>
-        <p:nvSpPr>
-          <p:cNvPr id="6" name="TextBox 5"/>
-          <p:cNvSpPr txBox="1"/>
-          <p:nvPr/>
-        </p:nvSpPr>
-        <p:spPr>
-          <a:xfrm>
-            <a:off x="7589520" y="1737360"/>
-            <a:ext cx="4206240" cy="4572000"/>
-          </a:xfrm>
-          <a:prstGeom prst="rect">
-            <a:avLst/>
-          </a:prstGeom>
-          <a:noFill/>
-        </p:spPr>
-        <p:txBody>
-          <a:bodyPr wrap="square">
-            <a:spAutoFit/>
-          </a:bodyPr>
-          <a:lstStyle/>
-          <a:p>
-            <a:pPr algn="l">
-              <a:spcAft>
-                <a:spcPts val="600"/>
-              </a:spcAft>
-            </a:pPr>
-            <a:r>
-              <a:rPr sz="1400">
-                <a:solidFill>
-                  <a:srgbClr val="1E2761"/>
-                </a:solidFill>
-                <a:latin typeface="Calibri"/>
-              </a:rPr>
-              <a:t>•  Windows — single-glazed dwellings carry the largest negative SHAP contributions; multi-glazed the largest positive. Top feature by permutation importance (Δ-QWK +0.088 on shuffle).</a:t>
-            </a:r>
-          </a:p>
-          <a:p>
-            <a:pPr algn="l">
-              <a:spcAft>
-                <a:spcPts val="600"/>
-              </a:spcAft>
-            </a:pPr>
-            <a:r>
-              <a:rPr sz="1400">
-                <a:solidFill>
-                  <a:srgbClr val="1E2761"/>
-                </a:solidFill>
-                <a:latin typeface="Calibri"/>
-              </a:rPr>
-              <a:t>•  Construction age — monotonic gradient reflecting four decades of Part L revisions (Spearman ρ 0.56 vs SAP).</a:t>
-            </a:r>
-          </a:p>
-          <a:p>
-            <a:pPr algn="l">
-              <a:spcAft>
-                <a:spcPts val="600"/>
-              </a:spcAft>
-            </a:pPr>
-            <a:r>
-              <a:rPr sz="1400">
-                <a:solidFill>
-                  <a:srgbClr val="1E2761"/>
-                </a:solidFill>
-                <a:latin typeface="Calibri"/>
-              </a:rPr>
-              <a:t>•  Main fuel and heating type — gas / condensing-boiler dwellings score higher; heat pumps do not improve the rating because SAP is cost-based and electricity is ≈ 3× more per kWh.</a:t>
-            </a:r>
-          </a:p>
-          <a:p>
-            <a:pPr algn="l">
-              <a:spcAft>
-                <a:spcPts val="600"/>
-              </a:spcAft>
-            </a:pPr>
-            <a:r>
-              <a:rPr sz="1400">
-                <a:solidFill>
-                  <a:srgbClr val="1E2761"/>
-                </a:solidFill>
-                <a:latin typeface="Calibri"/>
-              </a:rPr>
-              <a:t>•  Walls — solid-brick uninsulated drives negative SHAP; cavity-with-insulation positive (FLAG_SOLID_BRICK_BARE in top 10).</a:t>
-            </a:r>
-          </a:p>
-          <a:p>
-            <a:pPr algn="l">
-              <a:spcAft>
-                <a:spcPts val="600"/>
-              </a:spcAft>
-            </a:pPr>
-            <a:r>
-              <a:rPr sz="1400">
-                <a:solidFill>
-                  <a:srgbClr val="1E2761"/>
-                </a:solidFill>
-                <a:latin typeface="Calibri"/>
-              </a:rPr>
-              <a:t>•  Permutation importance and SHAP agree on the top features → robust signal, not algorithmic artefact.</a:t>
-            </a:r>
-          </a:p>
-        </p:txBody>
-      </p:sp>
-      <p:sp>
-        <p:nvSpPr>
-          <p:cNvPr id="7" name="TextBox 6"/>
+      <p:pic>
+        <p:nvPicPr>
+          <p:cNvPr id="18" name="Picture 17" descr="fig_calibration_C.png"/>
+          <p:cNvPicPr>
+            <a:picLocks noChangeAspect="1"/>
+          </p:cNvPicPr>
+          <p:nvPr/>
+        </p:nvPicPr>
+        <p:blipFill>
+          <a:blip r:embed="rId3"/>
+          <a:stretch>
+            <a:fillRect/>
+          </a:stretch>
+        </p:blipFill>
+        <p:spPr>
+          <a:xfrm>
+            <a:off x="6878122" y="2788920"/>
+            <a:ext cx="4257435" cy="3657600"/>
+          </a:xfrm>
+          <a:prstGeom prst="rect">
+            <a:avLst/>
+          </a:prstGeom>
+        </p:spPr>
+      </p:pic>
+      <p:sp>
+        <p:nvSpPr>
+          <p:cNvPr id="19" name="TextBox 18"/>
           <p:cNvSpPr txBox="1"/>
           <p:nvPr/>
         </p:nvSpPr>
@@ -3648,14 +4031,14 @@
                 </a:solidFill>
                 <a:latin typeface="Calibri"/>
               </a:rPr>
-              <a:t>COM6003 — Oxford EPC Analysis</a:t>
-            </a:r>
-          </a:p>
-        </p:txBody>
-      </p:sp>
-      <p:sp>
-        <p:nvSpPr>
-          <p:cNvPr id="8" name="TextBox 7"/>
+              <a:t>COM6003 • Oxford EPC Analysis</a:t>
+            </a:r>
+          </a:p>
+        </p:txBody>
+      </p:sp>
+      <p:sp>
+        <p:nvSpPr>
+          <p:cNvPr id="20" name="TextBox 19"/>
           <p:cNvSpPr txBox="1"/>
           <p:nvPr/>
         </p:nvSpPr>
@@ -3683,7 +4066,7 @@
                 </a:solidFill>
                 <a:latin typeface="Calibri"/>
               </a:rPr>
-              <a:t>10 / 12</a:t>
+              <a:t>10 / 14</a:t>
             </a:r>
           </a:p>
         </p:txBody>
@@ -3779,7 +4162,7 @@
                 </a:solidFill>
                 <a:latin typeface="Calibri"/>
               </a:rPr>
-              <a:t>Recommendations</a:t>
+              <a:t>What drives the rating</a:t>
             </a:r>
           </a:p>
         </p:txBody>
@@ -3814,54 +4197,35 @@
                 </a:solidFill>
                 <a:latin typeface="Calibri"/>
               </a:rPr>
-              <a:t>For Oxford City Council and registered providers</a:t>
-            </a:r>
-          </a:p>
-        </p:txBody>
-      </p:sp>
-      <p:sp>
-        <p:nvSpPr>
-          <p:cNvPr id="5" name="Oval 4"/>
-          <p:cNvSpPr/>
-          <p:nvPr/>
-        </p:nvSpPr>
-        <p:spPr>
-          <a:xfrm>
-            <a:off x="640080" y="1554480"/>
-            <a:ext cx="640080" cy="640080"/>
-          </a:xfrm>
-          <a:prstGeom prst="ellipse">
-            <a:avLst/>
-          </a:prstGeom>
-          <a:solidFill>
-            <a:srgbClr val="F9C177"/>
-          </a:solidFill>
-          <a:ln>
-            <a:noFill/>
-          </a:ln>
-        </p:spPr>
-        <p:style>
-          <a:lnRef idx="1">
-            <a:schemeClr val="accent1"/>
-          </a:lnRef>
-          <a:fillRef idx="3">
-            <a:schemeClr val="accent1"/>
-          </a:fillRef>
-          <a:effectRef idx="2">
-            <a:schemeClr val="accent1"/>
-          </a:effectRef>
-          <a:fontRef idx="minor">
-            <a:schemeClr val="lt1"/>
-          </a:fontRef>
-        </p:style>
-        <p:txBody>
-          <a:bodyPr rtlCol="0" anchor="ctr"/>
-          <a:lstStyle/>
-          <a:p>
-            <a:pPr algn="ctr"/>
-          </a:p>
-        </p:txBody>
-      </p:sp>
+              <a:t>Windows, construction age and main fuel dominate by permutation importance</a:t>
+            </a:r>
+          </a:p>
+        </p:txBody>
+      </p:sp>
+      <p:pic>
+        <p:nvPicPr>
+          <p:cNvPr id="5" name="Picture 4" descr="fig_shap_summary.png"/>
+          <p:cNvPicPr>
+            <a:picLocks noChangeAspect="1"/>
+          </p:cNvPicPr>
+          <p:nvPr/>
+        </p:nvPicPr>
+        <p:blipFill>
+          <a:blip r:embed="rId2"/>
+          <a:stretch>
+            <a:fillRect/>
+          </a:stretch>
+        </p:blipFill>
+        <p:spPr>
+          <a:xfrm>
+            <a:off x="1383278" y="2344288"/>
+            <a:ext cx="5188723" cy="3266703"/>
+          </a:xfrm>
+          <a:prstGeom prst="rect">
+            <a:avLst/>
+          </a:prstGeom>
+        </p:spPr>
+      </p:pic>
       <p:sp>
         <p:nvSpPr>
           <p:cNvPr id="6" name="TextBox 5"/>
@@ -3870,29 +4234,97 @@
         </p:nvSpPr>
         <p:spPr>
           <a:xfrm>
-            <a:off x="640080" y="1645920"/>
-            <a:ext cx="640080" cy="457200"/>
-          </a:xfrm>
-          <a:prstGeom prst="rect">
-            <a:avLst/>
-          </a:prstGeom>
-          <a:noFill/>
-        </p:spPr>
-        <p:txBody>
-          <a:bodyPr wrap="square" lIns="45720" rIns="45720" tIns="18288" bIns="18288">
-            <a:spAutoFit/>
-          </a:bodyPr>
-          <a:lstStyle/>
-          <a:p>
-            <a:pPr algn="ctr"/>
-            <a:r>
-              <a:rPr sz="1800" b="1" i="0">
+            <a:off x="7589520" y="1737360"/>
+            <a:ext cx="4206240" cy="4572000"/>
+          </a:xfrm>
+          <a:prstGeom prst="rect">
+            <a:avLst/>
+          </a:prstGeom>
+          <a:noFill/>
+        </p:spPr>
+        <p:txBody>
+          <a:bodyPr wrap="square">
+            <a:spAutoFit/>
+          </a:bodyPr>
+          <a:lstStyle/>
+          <a:p>
+            <a:pPr algn="l">
+              <a:spcAft>
+                <a:spcPts val="600"/>
+              </a:spcAft>
+            </a:pPr>
+            <a:r>
+              <a:rPr sz="1400">
                 <a:solidFill>
                   <a:srgbClr val="1E2761"/>
                 </a:solidFill>
                 <a:latin typeface="Calibri"/>
               </a:rPr>
-              <a:t>1.</a:t>
+              <a:t>•  Windows: single-glazed dwellings carry the largest negative SHAP contributions; multi-glazed the largest positive. Top feature by permutation importance (Δ-QWK +0.071 on shuffle).</a:t>
+            </a:r>
+          </a:p>
+          <a:p>
+            <a:pPr algn="l">
+              <a:spcAft>
+                <a:spcPts val="600"/>
+              </a:spcAft>
+            </a:pPr>
+            <a:r>
+              <a:rPr sz="1400">
+                <a:solidFill>
+                  <a:srgbClr val="1E2761"/>
+                </a:solidFill>
+                <a:latin typeface="Calibri"/>
+              </a:rPr>
+              <a:t>•  Construction age: monotonic gradient reflecting four decades of Part L revisions (Spearman ρ 0.62 vs SAP).</a:t>
+            </a:r>
+          </a:p>
+          <a:p>
+            <a:pPr algn="l">
+              <a:spcAft>
+                <a:spcPts val="600"/>
+              </a:spcAft>
+            </a:pPr>
+            <a:r>
+              <a:rPr sz="1400">
+                <a:solidFill>
+                  <a:srgbClr val="1E2761"/>
+                </a:solidFill>
+                <a:latin typeface="Calibri"/>
+              </a:rPr>
+              <a:t>•  Main fuel and heating type: gas / condensing-boiler dwellings score higher; heat pumps do not improve the rating because SAP is cost-based and electricity is ≈ 3× more per kWh.</a:t>
+            </a:r>
+          </a:p>
+          <a:p>
+            <a:pPr algn="l">
+              <a:spcAft>
+                <a:spcPts val="600"/>
+              </a:spcAft>
+            </a:pPr>
+            <a:r>
+              <a:rPr sz="1400">
+                <a:solidFill>
+                  <a:srgbClr val="1E2761"/>
+                </a:solidFill>
+                <a:latin typeface="Calibri"/>
+              </a:rPr>
+              <a:t>•  Walls: solid-brick uninsulated drives negative SHAP; cavity-with-insulation positive (FLAG_SOLID_BRICK_BARE in top 10).</a:t>
+            </a:r>
+          </a:p>
+          <a:p>
+            <a:pPr algn="l">
+              <a:spcAft>
+                <a:spcPts val="600"/>
+              </a:spcAft>
+            </a:pPr>
+            <a:r>
+              <a:rPr sz="1400">
+                <a:solidFill>
+                  <a:srgbClr val="1E2761"/>
+                </a:solidFill>
+                <a:latin typeface="Calibri"/>
+              </a:rPr>
+              <a:t>•  Permutation importance and SHAP agree on the top features → robust signal, not algorithmic artefact.</a:t>
             </a:r>
           </a:p>
         </p:txBody>
@@ -3900,668 +4332,6 @@
       <p:sp>
         <p:nvSpPr>
           <p:cNvPr id="7" name="TextBox 6"/>
-          <p:cNvSpPr txBox="1"/>
-          <p:nvPr/>
-        </p:nvSpPr>
-        <p:spPr>
-          <a:xfrm>
-            <a:off x="1463040" y="1600200"/>
-            <a:ext cx="10515600" cy="411480"/>
-          </a:xfrm>
-          <a:prstGeom prst="rect">
-            <a:avLst/>
-          </a:prstGeom>
-          <a:noFill/>
-        </p:spPr>
-        <p:txBody>
-          <a:bodyPr wrap="square" lIns="45720" rIns="45720" tIns="18288" bIns="18288">
-            <a:spAutoFit/>
-          </a:bodyPr>
-          <a:lstStyle/>
-          <a:p>
-            <a:pPr algn="l"/>
-            <a:r>
-              <a:rPr sz="1800" b="1" i="0">
-                <a:solidFill>
-                  <a:srgbClr val="1E2761"/>
-                </a:solidFill>
-                <a:latin typeface="Calibri"/>
-              </a:rPr>
-              <a:t>Solid-wall insulation in pre-1929 stock</a:t>
-            </a:r>
-          </a:p>
-        </p:txBody>
-      </p:sp>
-      <p:sp>
-        <p:nvSpPr>
-          <p:cNvPr id="8" name="TextBox 7"/>
-          <p:cNvSpPr txBox="1"/>
-          <p:nvPr/>
-        </p:nvSpPr>
-        <p:spPr>
-          <a:xfrm>
-            <a:off x="1463040" y="2011680"/>
-            <a:ext cx="10515600" cy="457200"/>
-          </a:xfrm>
-          <a:prstGeom prst="rect">
-            <a:avLst/>
-          </a:prstGeom>
-          <a:noFill/>
-        </p:spPr>
-        <p:txBody>
-          <a:bodyPr wrap="square" lIns="45720" rIns="45720" tIns="18288" bIns="18288">
-            <a:spAutoFit/>
-          </a:bodyPr>
-          <a:lstStyle/>
-          <a:p>
-            <a:pPr algn="l"/>
-            <a:r>
-              <a:rPr sz="1200" b="0" i="0">
-                <a:solidFill>
-                  <a:srgbClr val="4B556B"/>
-                </a:solidFill>
-                <a:latin typeface="Calibri"/>
-              </a:rPr>
-              <a:t>Largest single physical lever; £4–14k per dwelling; SAP-engine corroborates.</a:t>
-            </a:r>
-          </a:p>
-        </p:txBody>
-      </p:sp>
-      <p:sp>
-        <p:nvSpPr>
-          <p:cNvPr id="9" name="Oval 8"/>
-          <p:cNvSpPr/>
-          <p:nvPr/>
-        </p:nvSpPr>
-        <p:spPr>
-          <a:xfrm>
-            <a:off x="640080" y="2514600"/>
-            <a:ext cx="640080" cy="640080"/>
-          </a:xfrm>
-          <a:prstGeom prst="ellipse">
-            <a:avLst/>
-          </a:prstGeom>
-          <a:solidFill>
-            <a:srgbClr val="F9C177"/>
-          </a:solidFill>
-          <a:ln>
-            <a:noFill/>
-          </a:ln>
-        </p:spPr>
-        <p:style>
-          <a:lnRef idx="1">
-            <a:schemeClr val="accent1"/>
-          </a:lnRef>
-          <a:fillRef idx="3">
-            <a:schemeClr val="accent1"/>
-          </a:fillRef>
-          <a:effectRef idx="2">
-            <a:schemeClr val="accent1"/>
-          </a:effectRef>
-          <a:fontRef idx="minor">
-            <a:schemeClr val="lt1"/>
-          </a:fontRef>
-        </p:style>
-        <p:txBody>
-          <a:bodyPr rtlCol="0" anchor="ctr"/>
-          <a:lstStyle/>
-          <a:p>
-            <a:pPr algn="ctr"/>
-          </a:p>
-        </p:txBody>
-      </p:sp>
-      <p:sp>
-        <p:nvSpPr>
-          <p:cNvPr id="10" name="TextBox 9"/>
-          <p:cNvSpPr txBox="1"/>
-          <p:nvPr/>
-        </p:nvSpPr>
-        <p:spPr>
-          <a:xfrm>
-            <a:off x="640080" y="2606040"/>
-            <a:ext cx="640080" cy="457200"/>
-          </a:xfrm>
-          <a:prstGeom prst="rect">
-            <a:avLst/>
-          </a:prstGeom>
-          <a:noFill/>
-        </p:spPr>
-        <p:txBody>
-          <a:bodyPr wrap="square" lIns="45720" rIns="45720" tIns="18288" bIns="18288">
-            <a:spAutoFit/>
-          </a:bodyPr>
-          <a:lstStyle/>
-          <a:p>
-            <a:pPr algn="ctr"/>
-            <a:r>
-              <a:rPr sz="1800" b="1" i="0">
-                <a:solidFill>
-                  <a:srgbClr val="1E2761"/>
-                </a:solidFill>
-                <a:latin typeface="Calibri"/>
-              </a:rPr>
-              <a:t>2.</a:t>
-            </a:r>
-          </a:p>
-        </p:txBody>
-      </p:sp>
-      <p:sp>
-        <p:nvSpPr>
-          <p:cNvPr id="11" name="TextBox 10"/>
-          <p:cNvSpPr txBox="1"/>
-          <p:nvPr/>
-        </p:nvSpPr>
-        <p:spPr>
-          <a:xfrm>
-            <a:off x="1463040" y="2560320"/>
-            <a:ext cx="10515600" cy="411480"/>
-          </a:xfrm>
-          <a:prstGeom prst="rect">
-            <a:avLst/>
-          </a:prstGeom>
-          <a:noFill/>
-        </p:spPr>
-        <p:txBody>
-          <a:bodyPr wrap="square" lIns="45720" rIns="45720" tIns="18288" bIns="18288">
-            <a:spAutoFit/>
-          </a:bodyPr>
-          <a:lstStyle/>
-          <a:p>
-            <a:pPr algn="l"/>
-            <a:r>
-              <a:rPr sz="1800" b="1" i="0">
-                <a:solidFill>
-                  <a:srgbClr val="1E2761"/>
-                </a:solidFill>
-                <a:latin typeface="Calibri"/>
-              </a:rPr>
-              <a:t>Loft insulation top-ups to ≥ 270 mm</a:t>
-            </a:r>
-          </a:p>
-        </p:txBody>
-      </p:sp>
-      <p:sp>
-        <p:nvSpPr>
-          <p:cNvPr id="12" name="TextBox 11"/>
-          <p:cNvSpPr txBox="1"/>
-          <p:nvPr/>
-        </p:nvSpPr>
-        <p:spPr>
-          <a:xfrm>
-            <a:off x="1463040" y="2971800"/>
-            <a:ext cx="10515600" cy="457200"/>
-          </a:xfrm>
-          <a:prstGeom prst="rect">
-            <a:avLst/>
-          </a:prstGeom>
-          <a:noFill/>
-        </p:spPr>
-        <p:txBody>
-          <a:bodyPr wrap="square" lIns="45720" rIns="45720" tIns="18288" bIns="18288">
-            <a:spAutoFit/>
-          </a:bodyPr>
-          <a:lstStyle/>
-          <a:p>
-            <a:pPr algn="l"/>
-            <a:r>
-              <a:rPr sz="1200" b="0" i="0">
-                <a:solidFill>
-                  <a:srgbClr val="4B556B"/>
-                </a:solidFill>
-                <a:latin typeface="Calibri"/>
-              </a:rPr>
-              <a:t>Cheapest material intervention; positive SHAP across nearly all bands.</a:t>
-            </a:r>
-          </a:p>
-        </p:txBody>
-      </p:sp>
-      <p:sp>
-        <p:nvSpPr>
-          <p:cNvPr id="13" name="Oval 12"/>
-          <p:cNvSpPr/>
-          <p:nvPr/>
-        </p:nvSpPr>
-        <p:spPr>
-          <a:xfrm>
-            <a:off x="640080" y="3474720"/>
-            <a:ext cx="640080" cy="640080"/>
-          </a:xfrm>
-          <a:prstGeom prst="ellipse">
-            <a:avLst/>
-          </a:prstGeom>
-          <a:solidFill>
-            <a:srgbClr val="F9C177"/>
-          </a:solidFill>
-          <a:ln>
-            <a:noFill/>
-          </a:ln>
-        </p:spPr>
-        <p:style>
-          <a:lnRef idx="1">
-            <a:schemeClr val="accent1"/>
-          </a:lnRef>
-          <a:fillRef idx="3">
-            <a:schemeClr val="accent1"/>
-          </a:fillRef>
-          <a:effectRef idx="2">
-            <a:schemeClr val="accent1"/>
-          </a:effectRef>
-          <a:fontRef idx="minor">
-            <a:schemeClr val="lt1"/>
-          </a:fontRef>
-        </p:style>
-        <p:txBody>
-          <a:bodyPr rtlCol="0" anchor="ctr"/>
-          <a:lstStyle/>
-          <a:p>
-            <a:pPr algn="ctr"/>
-          </a:p>
-        </p:txBody>
-      </p:sp>
-      <p:sp>
-        <p:nvSpPr>
-          <p:cNvPr id="14" name="TextBox 13"/>
-          <p:cNvSpPr txBox="1"/>
-          <p:nvPr/>
-        </p:nvSpPr>
-        <p:spPr>
-          <a:xfrm>
-            <a:off x="640080" y="3566160"/>
-            <a:ext cx="640080" cy="457200"/>
-          </a:xfrm>
-          <a:prstGeom prst="rect">
-            <a:avLst/>
-          </a:prstGeom>
-          <a:noFill/>
-        </p:spPr>
-        <p:txBody>
-          <a:bodyPr wrap="square" lIns="45720" rIns="45720" tIns="18288" bIns="18288">
-            <a:spAutoFit/>
-          </a:bodyPr>
-          <a:lstStyle/>
-          <a:p>
-            <a:pPr algn="ctr"/>
-            <a:r>
-              <a:rPr sz="1800" b="1" i="0">
-                <a:solidFill>
-                  <a:srgbClr val="1E2761"/>
-                </a:solidFill>
-                <a:latin typeface="Calibri"/>
-              </a:rPr>
-              <a:t>3.</a:t>
-            </a:r>
-          </a:p>
-        </p:txBody>
-      </p:sp>
-      <p:sp>
-        <p:nvSpPr>
-          <p:cNvPr id="15" name="TextBox 14"/>
-          <p:cNvSpPr txBox="1"/>
-          <p:nvPr/>
-        </p:nvSpPr>
-        <p:spPr>
-          <a:xfrm>
-            <a:off x="1463040" y="3520440"/>
-            <a:ext cx="10515600" cy="411480"/>
-          </a:xfrm>
-          <a:prstGeom prst="rect">
-            <a:avLst/>
-          </a:prstGeom>
-          <a:noFill/>
-        </p:spPr>
-        <p:txBody>
-          <a:bodyPr wrap="square" lIns="45720" rIns="45720" tIns="18288" bIns="18288">
-            <a:spAutoFit/>
-          </a:bodyPr>
-          <a:lstStyle/>
-          <a:p>
-            <a:pPr algn="l"/>
-            <a:r>
-              <a:rPr sz="1800" b="1" i="0">
-                <a:solidFill>
-                  <a:srgbClr val="1E2761"/>
-                </a:solidFill>
-                <a:latin typeface="Calibri"/>
-              </a:rPr>
-              <a:t>Replace single glazing in 1900–1949 cohort</a:t>
-            </a:r>
-          </a:p>
-        </p:txBody>
-      </p:sp>
-      <p:sp>
-        <p:nvSpPr>
-          <p:cNvPr id="16" name="TextBox 15"/>
-          <p:cNvSpPr txBox="1"/>
-          <p:nvPr/>
-        </p:nvSpPr>
-        <p:spPr>
-          <a:xfrm>
-            <a:off x="1463040" y="3931920"/>
-            <a:ext cx="10515600" cy="457200"/>
-          </a:xfrm>
-          <a:prstGeom prst="rect">
-            <a:avLst/>
-          </a:prstGeom>
-          <a:noFill/>
-        </p:spPr>
-        <p:txBody>
-          <a:bodyPr wrap="square" lIns="45720" rIns="45720" tIns="18288" bIns="18288">
-            <a:spAutoFit/>
-          </a:bodyPr>
-          <a:lstStyle/>
-          <a:p>
-            <a:pPr algn="l"/>
-            <a:r>
-              <a:rPr sz="1200" b="0" i="0">
-                <a:solidFill>
-                  <a:srgbClr val="4B556B"/>
-                </a:solidFill>
-                <a:latin typeface="Calibri"/>
-              </a:rPr>
-              <a:t>Concentration of FLAG_SINGLE_GLAZED; immediate comfort benefit.</a:t>
-            </a:r>
-          </a:p>
-        </p:txBody>
-      </p:sp>
-      <p:sp>
-        <p:nvSpPr>
-          <p:cNvPr id="17" name="Oval 16"/>
-          <p:cNvSpPr/>
-          <p:nvPr/>
-        </p:nvSpPr>
-        <p:spPr>
-          <a:xfrm>
-            <a:off x="640080" y="4434840"/>
-            <a:ext cx="640080" cy="640080"/>
-          </a:xfrm>
-          <a:prstGeom prst="ellipse">
-            <a:avLst/>
-          </a:prstGeom>
-          <a:solidFill>
-            <a:srgbClr val="F9C177"/>
-          </a:solidFill>
-          <a:ln>
-            <a:noFill/>
-          </a:ln>
-        </p:spPr>
-        <p:style>
-          <a:lnRef idx="1">
-            <a:schemeClr val="accent1"/>
-          </a:lnRef>
-          <a:fillRef idx="3">
-            <a:schemeClr val="accent1"/>
-          </a:fillRef>
-          <a:effectRef idx="2">
-            <a:schemeClr val="accent1"/>
-          </a:effectRef>
-          <a:fontRef idx="minor">
-            <a:schemeClr val="lt1"/>
-          </a:fontRef>
-        </p:style>
-        <p:txBody>
-          <a:bodyPr rtlCol="0" anchor="ctr"/>
-          <a:lstStyle/>
-          <a:p>
-            <a:pPr algn="ctr"/>
-          </a:p>
-        </p:txBody>
-      </p:sp>
-      <p:sp>
-        <p:nvSpPr>
-          <p:cNvPr id="18" name="TextBox 17"/>
-          <p:cNvSpPr txBox="1"/>
-          <p:nvPr/>
-        </p:nvSpPr>
-        <p:spPr>
-          <a:xfrm>
-            <a:off x="640080" y="4526280"/>
-            <a:ext cx="640080" cy="457200"/>
-          </a:xfrm>
-          <a:prstGeom prst="rect">
-            <a:avLst/>
-          </a:prstGeom>
-          <a:noFill/>
-        </p:spPr>
-        <p:txBody>
-          <a:bodyPr wrap="square" lIns="45720" rIns="45720" tIns="18288" bIns="18288">
-            <a:spAutoFit/>
-          </a:bodyPr>
-          <a:lstStyle/>
-          <a:p>
-            <a:pPr algn="ctr"/>
-            <a:r>
-              <a:rPr sz="1800" b="1" i="0">
-                <a:solidFill>
-                  <a:srgbClr val="1E2761"/>
-                </a:solidFill>
-                <a:latin typeface="Calibri"/>
-              </a:rPr>
-              <a:t>4.</a:t>
-            </a:r>
-          </a:p>
-        </p:txBody>
-      </p:sp>
-      <p:sp>
-        <p:nvSpPr>
-          <p:cNvPr id="19" name="TextBox 18"/>
-          <p:cNvSpPr txBox="1"/>
-          <p:nvPr/>
-        </p:nvSpPr>
-        <p:spPr>
-          <a:xfrm>
-            <a:off x="1463040" y="4480560"/>
-            <a:ext cx="10515600" cy="411480"/>
-          </a:xfrm>
-          <a:prstGeom prst="rect">
-            <a:avLst/>
-          </a:prstGeom>
-          <a:noFill/>
-        </p:spPr>
-        <p:txBody>
-          <a:bodyPr wrap="square" lIns="45720" rIns="45720" tIns="18288" bIns="18288">
-            <a:spAutoFit/>
-          </a:bodyPr>
-          <a:lstStyle/>
-          <a:p>
-            <a:pPr algn="l"/>
-            <a:r>
-              <a:rPr sz="1800" b="1" i="0">
-                <a:solidFill>
-                  <a:srgbClr val="1E2761"/>
-                </a:solidFill>
-                <a:latin typeface="Calibri"/>
-              </a:rPr>
-              <a:t>Communicate the heat-pump SAP caveat</a:t>
-            </a:r>
-          </a:p>
-        </p:txBody>
-      </p:sp>
-      <p:sp>
-        <p:nvSpPr>
-          <p:cNvPr id="20" name="TextBox 19"/>
-          <p:cNvSpPr txBox="1"/>
-          <p:nvPr/>
-        </p:nvSpPr>
-        <p:spPr>
-          <a:xfrm>
-            <a:off x="1463040" y="4892040"/>
-            <a:ext cx="10515600" cy="457200"/>
-          </a:xfrm>
-          <a:prstGeom prst="rect">
-            <a:avLst/>
-          </a:prstGeom>
-          <a:noFill/>
-        </p:spPr>
-        <p:txBody>
-          <a:bodyPr wrap="square" lIns="45720" rIns="45720" tIns="18288" bIns="18288">
-            <a:spAutoFit/>
-          </a:bodyPr>
-          <a:lstStyle/>
-          <a:p>
-            <a:pPr algn="l"/>
-            <a:r>
-              <a:rPr sz="1200" b="0" i="0">
-                <a:solidFill>
-                  <a:srgbClr val="4B556B"/>
-                </a:solidFill>
-                <a:latin typeface="Calibri"/>
-              </a:rPr>
-              <a:t>SAP is cost-based; tariff differential blunts rating gain — manage expectations.</a:t>
-            </a:r>
-          </a:p>
-        </p:txBody>
-      </p:sp>
-      <p:sp>
-        <p:nvSpPr>
-          <p:cNvPr id="21" name="Oval 20"/>
-          <p:cNvSpPr/>
-          <p:nvPr/>
-        </p:nvSpPr>
-        <p:spPr>
-          <a:xfrm>
-            <a:off x="640080" y="5394960"/>
-            <a:ext cx="640080" cy="640080"/>
-          </a:xfrm>
-          <a:prstGeom prst="ellipse">
-            <a:avLst/>
-          </a:prstGeom>
-          <a:solidFill>
-            <a:srgbClr val="F9C177"/>
-          </a:solidFill>
-          <a:ln>
-            <a:noFill/>
-          </a:ln>
-        </p:spPr>
-        <p:style>
-          <a:lnRef idx="1">
-            <a:schemeClr val="accent1"/>
-          </a:lnRef>
-          <a:fillRef idx="3">
-            <a:schemeClr val="accent1"/>
-          </a:fillRef>
-          <a:effectRef idx="2">
-            <a:schemeClr val="accent1"/>
-          </a:effectRef>
-          <a:fontRef idx="minor">
-            <a:schemeClr val="lt1"/>
-          </a:fontRef>
-        </p:style>
-        <p:txBody>
-          <a:bodyPr rtlCol="0" anchor="ctr"/>
-          <a:lstStyle/>
-          <a:p>
-            <a:pPr algn="ctr"/>
-          </a:p>
-        </p:txBody>
-      </p:sp>
-      <p:sp>
-        <p:nvSpPr>
-          <p:cNvPr id="22" name="TextBox 21"/>
-          <p:cNvSpPr txBox="1"/>
-          <p:nvPr/>
-        </p:nvSpPr>
-        <p:spPr>
-          <a:xfrm>
-            <a:off x="640080" y="5486400"/>
-            <a:ext cx="640080" cy="457200"/>
-          </a:xfrm>
-          <a:prstGeom prst="rect">
-            <a:avLst/>
-          </a:prstGeom>
-          <a:noFill/>
-        </p:spPr>
-        <p:txBody>
-          <a:bodyPr wrap="square" lIns="45720" rIns="45720" tIns="18288" bIns="18288">
-            <a:spAutoFit/>
-          </a:bodyPr>
-          <a:lstStyle/>
-          <a:p>
-            <a:pPr algn="ctr"/>
-            <a:r>
-              <a:rPr sz="1800" b="1" i="0">
-                <a:solidFill>
-                  <a:srgbClr val="1E2761"/>
-                </a:solidFill>
-                <a:latin typeface="Calibri"/>
-              </a:rPr>
-              <a:t>5.</a:t>
-            </a:r>
-          </a:p>
-        </p:txBody>
-      </p:sp>
-      <p:sp>
-        <p:nvSpPr>
-          <p:cNvPr id="23" name="TextBox 22"/>
-          <p:cNvSpPr txBox="1"/>
-          <p:nvPr/>
-        </p:nvSpPr>
-        <p:spPr>
-          <a:xfrm>
-            <a:off x="1463040" y="5440680"/>
-            <a:ext cx="10515600" cy="411480"/>
-          </a:xfrm>
-          <a:prstGeom prst="rect">
-            <a:avLst/>
-          </a:prstGeom>
-          <a:noFill/>
-        </p:spPr>
-        <p:txBody>
-          <a:bodyPr wrap="square" lIns="45720" rIns="45720" tIns="18288" bIns="18288">
-            <a:spAutoFit/>
-          </a:bodyPr>
-          <a:lstStyle/>
-          <a:p>
-            <a:pPr algn="l"/>
-            <a:r>
-              <a:rPr sz="1800" b="1" i="0">
-                <a:solidFill>
-                  <a:srgbClr val="1E2761"/>
-                </a:solidFill>
-                <a:latin typeface="Calibri"/>
-              </a:rPr>
-              <a:t>Geographic targeting — OX1 / OX2 / OX4</a:t>
-            </a:r>
-          </a:p>
-        </p:txBody>
-      </p:sp>
-      <p:sp>
-        <p:nvSpPr>
-          <p:cNvPr id="24" name="TextBox 23"/>
-          <p:cNvSpPr txBox="1"/>
-          <p:nvPr/>
-        </p:nvSpPr>
-        <p:spPr>
-          <a:xfrm>
-            <a:off x="1463040" y="5852160"/>
-            <a:ext cx="10515600" cy="457200"/>
-          </a:xfrm>
-          <a:prstGeom prst="rect">
-            <a:avLst/>
-          </a:prstGeom>
-          <a:noFill/>
-        </p:spPr>
-        <p:txBody>
-          <a:bodyPr wrap="square" lIns="45720" rIns="45720" tIns="18288" bIns="18288">
-            <a:spAutoFit/>
-          </a:bodyPr>
-          <a:lstStyle/>
-          <a:p>
-            <a:pPr algn="l"/>
-            <a:r>
-              <a:rPr sz="1200" b="0" i="0">
-                <a:solidFill>
-                  <a:srgbClr val="4B556B"/>
-                </a:solidFill>
-                <a:latin typeface="Calibri"/>
-              </a:rPr>
-              <a:t>Highest density of pre-1900 stock; district-weighted subsidies. Operational deliverable: reports/predictions_oxford.csv (76,400 per-UPRN predictions + confidence proxy).</a:t>
-            </a:r>
-          </a:p>
-        </p:txBody>
-      </p:sp>
-      <p:sp>
-        <p:nvSpPr>
-          <p:cNvPr id="25" name="TextBox 24"/>
           <p:cNvSpPr txBox="1"/>
           <p:nvPr/>
         </p:nvSpPr>
@@ -4589,14 +4359,14 @@
                 </a:solidFill>
                 <a:latin typeface="Calibri"/>
               </a:rPr>
-              <a:t>COM6003 — Oxford EPC Analysis</a:t>
-            </a:r>
-          </a:p>
-        </p:txBody>
-      </p:sp>
-      <p:sp>
-        <p:nvSpPr>
-          <p:cNvPr id="26" name="TextBox 25"/>
+              <a:t>COM6003 • Oxford EPC Analysis</a:t>
+            </a:r>
+          </a:p>
+        </p:txBody>
+      </p:sp>
+      <p:sp>
+        <p:nvSpPr>
+          <p:cNvPr id="8" name="TextBox 7"/>
           <p:cNvSpPr txBox="1"/>
           <p:nvPr/>
         </p:nvSpPr>
@@ -4624,7 +4394,7 @@
                 </a:solidFill>
                 <a:latin typeface="Calibri"/>
               </a:rPr>
-              <a:t>11 / 12</a:t>
+              <a:t>11 / 14</a:t>
             </a:r>
           </a:p>
         </p:txBody>
@@ -4656,7 +4426,7 @@
         <p:spPr>
           <a:xfrm>
             <a:off x="0" y="0"/>
-            <a:ext cx="12191695" cy="6858000"/>
+            <a:ext cx="164592" cy="6858000"/>
           </a:xfrm>
           <a:prstGeom prst="rect">
             <a:avLst/>
@@ -4698,6 +4468,1656 @@
         </p:nvSpPr>
         <p:spPr>
           <a:xfrm>
+            <a:off x="502920" y="292608"/>
+            <a:ext cx="10972800" cy="640080"/>
+          </a:xfrm>
+          <a:prstGeom prst="rect">
+            <a:avLst/>
+          </a:prstGeom>
+          <a:noFill/>
+        </p:spPr>
+        <p:txBody>
+          <a:bodyPr wrap="square" lIns="45720" rIns="45720" tIns="18288" bIns="18288">
+            <a:spAutoFit/>
+          </a:bodyPr>
+          <a:lstStyle/>
+          <a:p>
+            <a:pPr algn="l"/>
+            <a:r>
+              <a:rPr sz="3000" b="1" i="0">
+                <a:solidFill>
+                  <a:srgbClr val="1E2761"/>
+                </a:solidFill>
+                <a:latin typeface="Calibri"/>
+              </a:rPr>
+              <a:t>Unsupervised segmentation and retrofit recommender</a:t>
+            </a:r>
+          </a:p>
+        </p:txBody>
+      </p:sp>
+      <p:sp>
+        <p:nvSpPr>
+          <p:cNvPr id="4" name="TextBox 3"/>
+          <p:cNvSpPr txBox="1"/>
+          <p:nvPr/>
+        </p:nvSpPr>
+        <p:spPr>
+          <a:xfrm>
+            <a:off x="502920" y="868680"/>
+            <a:ext cx="10972800" cy="365760"/>
+          </a:xfrm>
+          <a:prstGeom prst="rect">
+            <a:avLst/>
+          </a:prstGeom>
+          <a:noFill/>
+        </p:spPr>
+        <p:txBody>
+          <a:bodyPr wrap="square" lIns="45720" rIns="45720" tIns="18288" bIns="18288">
+            <a:spAutoFit/>
+          </a:bodyPr>
+          <a:lstStyle/>
+          <a:p>
+            <a:pPr algn="l"/>
+            <a:r>
+              <a:rPr sz="1400" b="0" i="1">
+                <a:solidFill>
+                  <a:srgbClr val="4B556B"/>
+                </a:solidFill>
+                <a:latin typeface="Calibri"/>
+              </a:rPr>
+              <a:t>Three fabric archetypes (K-Prototypes, k = 3) and an Apriori + content-based k-NN recommender</a:t>
+            </a:r>
+          </a:p>
+        </p:txBody>
+      </p:sp>
+      <p:sp>
+        <p:nvSpPr>
+          <p:cNvPr id="5" name="Rounded Rectangle 4"/>
+          <p:cNvSpPr/>
+          <p:nvPr/>
+        </p:nvSpPr>
+        <p:spPr>
+          <a:xfrm>
+            <a:off x="640080" y="1554480"/>
+            <a:ext cx="2606040" cy="1097280"/>
+          </a:xfrm>
+          <a:prstGeom prst="roundRect">
+            <a:avLst/>
+          </a:prstGeom>
+          <a:solidFill>
+            <a:srgbClr val="F5F7FB"/>
+          </a:solidFill>
+          <a:ln>
+            <a:solidFill>
+              <a:srgbClr val="CADCFC"/>
+            </a:solidFill>
+          </a:ln>
+        </p:spPr>
+        <p:style>
+          <a:lnRef idx="1">
+            <a:schemeClr val="accent1"/>
+          </a:lnRef>
+          <a:fillRef idx="3">
+            <a:schemeClr val="accent1"/>
+          </a:fillRef>
+          <a:effectRef idx="2">
+            <a:schemeClr val="accent1"/>
+          </a:effectRef>
+          <a:fontRef idx="minor">
+            <a:schemeClr val="lt1"/>
+          </a:fontRef>
+        </p:style>
+        <p:txBody>
+          <a:bodyPr rtlCol="0" anchor="ctr"/>
+          <a:lstStyle/>
+          <a:p>
+            <a:pPr algn="ctr"/>
+          </a:p>
+        </p:txBody>
+      </p:sp>
+      <p:sp>
+        <p:nvSpPr>
+          <p:cNvPr id="6" name="TextBox 5"/>
+          <p:cNvSpPr txBox="1"/>
+          <p:nvPr/>
+        </p:nvSpPr>
+        <p:spPr>
+          <a:xfrm>
+            <a:off x="731520" y="1627632"/>
+            <a:ext cx="2423160" cy="457200"/>
+          </a:xfrm>
+          <a:prstGeom prst="rect">
+            <a:avLst/>
+          </a:prstGeom>
+          <a:noFill/>
+        </p:spPr>
+        <p:txBody>
+          <a:bodyPr wrap="square" lIns="45720" rIns="45720" tIns="18288" bIns="18288">
+            <a:spAutoFit/>
+          </a:bodyPr>
+          <a:lstStyle/>
+          <a:p>
+            <a:pPr algn="l"/>
+            <a:r>
+              <a:rPr sz="2800" b="1" i="0">
+                <a:solidFill>
+                  <a:srgbClr val="1E2761"/>
+                </a:solidFill>
+                <a:latin typeface="Calibri"/>
+              </a:rPr>
+              <a:t>k = 3</a:t>
+            </a:r>
+          </a:p>
+        </p:txBody>
+      </p:sp>
+      <p:sp>
+        <p:nvSpPr>
+          <p:cNvPr id="7" name="TextBox 6"/>
+          <p:cNvSpPr txBox="1"/>
+          <p:nvPr/>
+        </p:nvSpPr>
+        <p:spPr>
+          <a:xfrm>
+            <a:off x="731520" y="2194560"/>
+            <a:ext cx="2423160" cy="365760"/>
+          </a:xfrm>
+          <a:prstGeom prst="rect">
+            <a:avLst/>
+          </a:prstGeom>
+          <a:noFill/>
+        </p:spPr>
+        <p:txBody>
+          <a:bodyPr wrap="square" lIns="45720" rIns="45720" tIns="18288" bIns="18288">
+            <a:spAutoFit/>
+          </a:bodyPr>
+          <a:lstStyle/>
+          <a:p>
+            <a:pPr algn="l"/>
+            <a:r>
+              <a:rPr sz="1100" b="0" i="0">
+                <a:solidFill>
+                  <a:srgbClr val="4B556B"/>
+                </a:solidFill>
+                <a:latin typeface="Calibri"/>
+              </a:rPr>
+              <a:t>K-Prototypes segments</a:t>
+            </a:r>
+          </a:p>
+        </p:txBody>
+      </p:sp>
+      <p:sp>
+        <p:nvSpPr>
+          <p:cNvPr id="8" name="Rounded Rectangle 7"/>
+          <p:cNvSpPr/>
+          <p:nvPr/>
+        </p:nvSpPr>
+        <p:spPr>
+          <a:xfrm>
+            <a:off x="3429000" y="1554480"/>
+            <a:ext cx="2606040" cy="1097280"/>
+          </a:xfrm>
+          <a:prstGeom prst="roundRect">
+            <a:avLst/>
+          </a:prstGeom>
+          <a:solidFill>
+            <a:srgbClr val="F5F7FB"/>
+          </a:solidFill>
+          <a:ln>
+            <a:solidFill>
+              <a:srgbClr val="CADCFC"/>
+            </a:solidFill>
+          </a:ln>
+        </p:spPr>
+        <p:style>
+          <a:lnRef idx="1">
+            <a:schemeClr val="accent1"/>
+          </a:lnRef>
+          <a:fillRef idx="3">
+            <a:schemeClr val="accent1"/>
+          </a:fillRef>
+          <a:effectRef idx="2">
+            <a:schemeClr val="accent1"/>
+          </a:effectRef>
+          <a:fontRef idx="minor">
+            <a:schemeClr val="lt1"/>
+          </a:fontRef>
+        </p:style>
+        <p:txBody>
+          <a:bodyPr rtlCol="0" anchor="ctr"/>
+          <a:lstStyle/>
+          <a:p>
+            <a:pPr algn="ctr"/>
+          </a:p>
+        </p:txBody>
+      </p:sp>
+      <p:sp>
+        <p:nvSpPr>
+          <p:cNvPr id="9" name="TextBox 8"/>
+          <p:cNvSpPr txBox="1"/>
+          <p:nvPr/>
+        </p:nvSpPr>
+        <p:spPr>
+          <a:xfrm>
+            <a:off x="3520440" y="1627632"/>
+            <a:ext cx="2423160" cy="457200"/>
+          </a:xfrm>
+          <a:prstGeom prst="rect">
+            <a:avLst/>
+          </a:prstGeom>
+          <a:noFill/>
+        </p:spPr>
+        <p:txBody>
+          <a:bodyPr wrap="square" lIns="45720" rIns="45720" tIns="18288" bIns="18288">
+            <a:spAutoFit/>
+          </a:bodyPr>
+          <a:lstStyle/>
+          <a:p>
+            <a:pPr algn="l"/>
+            <a:r>
+              <a:rPr sz="2800" b="1" i="0">
+                <a:solidFill>
+                  <a:srgbClr val="1E2761"/>
+                </a:solidFill>
+                <a:latin typeface="Calibri"/>
+              </a:rPr>
+              <a:t>0.24</a:t>
+            </a:r>
+          </a:p>
+        </p:txBody>
+      </p:sp>
+      <p:sp>
+        <p:nvSpPr>
+          <p:cNvPr id="10" name="TextBox 9"/>
+          <p:cNvSpPr txBox="1"/>
+          <p:nvPr/>
+        </p:nvSpPr>
+        <p:spPr>
+          <a:xfrm>
+            <a:off x="3520440" y="2194560"/>
+            <a:ext cx="2423160" cy="365760"/>
+          </a:xfrm>
+          <a:prstGeom prst="rect">
+            <a:avLst/>
+          </a:prstGeom>
+          <a:noFill/>
+        </p:spPr>
+        <p:txBody>
+          <a:bodyPr wrap="square" lIns="45720" rIns="45720" tIns="18288" bIns="18288">
+            <a:spAutoFit/>
+          </a:bodyPr>
+          <a:lstStyle/>
+          <a:p>
+            <a:pPr algn="l"/>
+            <a:r>
+              <a:rPr sz="1100" b="0" i="0">
+                <a:solidFill>
+                  <a:srgbClr val="4B556B"/>
+                </a:solidFill>
+                <a:latin typeface="Calibri"/>
+              </a:rPr>
+              <a:t>Gower silhouette (soft archetypes)</a:t>
+            </a:r>
+          </a:p>
+        </p:txBody>
+      </p:sp>
+      <p:sp>
+        <p:nvSpPr>
+          <p:cNvPr id="11" name="Rounded Rectangle 10"/>
+          <p:cNvSpPr/>
+          <p:nvPr/>
+        </p:nvSpPr>
+        <p:spPr>
+          <a:xfrm>
+            <a:off x="6217920" y="1554480"/>
+            <a:ext cx="2606040" cy="1097280"/>
+          </a:xfrm>
+          <a:prstGeom prst="roundRect">
+            <a:avLst/>
+          </a:prstGeom>
+          <a:solidFill>
+            <a:srgbClr val="F5F7FB"/>
+          </a:solidFill>
+          <a:ln>
+            <a:solidFill>
+              <a:srgbClr val="CADCFC"/>
+            </a:solidFill>
+          </a:ln>
+        </p:spPr>
+        <p:style>
+          <a:lnRef idx="1">
+            <a:schemeClr val="accent1"/>
+          </a:lnRef>
+          <a:fillRef idx="3">
+            <a:schemeClr val="accent1"/>
+          </a:fillRef>
+          <a:effectRef idx="2">
+            <a:schemeClr val="accent1"/>
+          </a:effectRef>
+          <a:fontRef idx="minor">
+            <a:schemeClr val="lt1"/>
+          </a:fontRef>
+        </p:style>
+        <p:txBody>
+          <a:bodyPr rtlCol="0" anchor="ctr"/>
+          <a:lstStyle/>
+          <a:p>
+            <a:pPr algn="ctr"/>
+          </a:p>
+        </p:txBody>
+      </p:sp>
+      <p:sp>
+        <p:nvSpPr>
+          <p:cNvPr id="12" name="TextBox 11"/>
+          <p:cNvSpPr txBox="1"/>
+          <p:nvPr/>
+        </p:nvSpPr>
+        <p:spPr>
+          <a:xfrm>
+            <a:off x="6309360" y="1627632"/>
+            <a:ext cx="2423160" cy="457200"/>
+          </a:xfrm>
+          <a:prstGeom prst="rect">
+            <a:avLst/>
+          </a:prstGeom>
+          <a:noFill/>
+        </p:spPr>
+        <p:txBody>
+          <a:bodyPr wrap="square" lIns="45720" rIns="45720" tIns="18288" bIns="18288">
+            <a:spAutoFit/>
+          </a:bodyPr>
+          <a:lstStyle/>
+          <a:p>
+            <a:pPr algn="l"/>
+            <a:r>
+              <a:rPr sz="2800" b="1" i="0">
+                <a:solidFill>
+                  <a:srgbClr val="1E2761"/>
+                </a:solidFill>
+                <a:latin typeface="Calibri"/>
+              </a:rPr>
+              <a:t>8.9</a:t>
+            </a:r>
+          </a:p>
+        </p:txBody>
+      </p:sp>
+      <p:sp>
+        <p:nvSpPr>
+          <p:cNvPr id="13" name="TextBox 12"/>
+          <p:cNvSpPr txBox="1"/>
+          <p:nvPr/>
+        </p:nvSpPr>
+        <p:spPr>
+          <a:xfrm>
+            <a:off x="6309360" y="2194560"/>
+            <a:ext cx="2423160" cy="365760"/>
+          </a:xfrm>
+          <a:prstGeom prst="rect">
+            <a:avLst/>
+          </a:prstGeom>
+          <a:noFill/>
+        </p:spPr>
+        <p:txBody>
+          <a:bodyPr wrap="square" lIns="45720" rIns="45720" tIns="18288" bIns="18288">
+            <a:spAutoFit/>
+          </a:bodyPr>
+          <a:lstStyle/>
+          <a:p>
+            <a:pPr algn="l"/>
+            <a:r>
+              <a:rPr sz="1100" b="0" i="0">
+                <a:solidFill>
+                  <a:srgbClr val="4B556B"/>
+                </a:solidFill>
+                <a:latin typeface="Calibri"/>
+              </a:rPr>
+              <a:t>Top Apriori rule lift</a:t>
+            </a:r>
+          </a:p>
+        </p:txBody>
+      </p:sp>
+      <p:sp>
+        <p:nvSpPr>
+          <p:cNvPr id="14" name="Rounded Rectangle 13"/>
+          <p:cNvSpPr/>
+          <p:nvPr/>
+        </p:nvSpPr>
+        <p:spPr>
+          <a:xfrm>
+            <a:off x="9006839" y="1554480"/>
+            <a:ext cx="2606040" cy="1097280"/>
+          </a:xfrm>
+          <a:prstGeom prst="roundRect">
+            <a:avLst/>
+          </a:prstGeom>
+          <a:solidFill>
+            <a:srgbClr val="F5F7FB"/>
+          </a:solidFill>
+          <a:ln>
+            <a:solidFill>
+              <a:srgbClr val="CADCFC"/>
+            </a:solidFill>
+          </a:ln>
+        </p:spPr>
+        <p:style>
+          <a:lnRef idx="1">
+            <a:schemeClr val="accent1"/>
+          </a:lnRef>
+          <a:fillRef idx="3">
+            <a:schemeClr val="accent1"/>
+          </a:fillRef>
+          <a:effectRef idx="2">
+            <a:schemeClr val="accent1"/>
+          </a:effectRef>
+          <a:fontRef idx="minor">
+            <a:schemeClr val="lt1"/>
+          </a:fontRef>
+        </p:style>
+        <p:txBody>
+          <a:bodyPr rtlCol="0" anchor="ctr"/>
+          <a:lstStyle/>
+          <a:p>
+            <a:pPr algn="ctr"/>
+          </a:p>
+        </p:txBody>
+      </p:sp>
+      <p:sp>
+        <p:nvSpPr>
+          <p:cNvPr id="15" name="TextBox 14"/>
+          <p:cNvSpPr txBox="1"/>
+          <p:nvPr/>
+        </p:nvSpPr>
+        <p:spPr>
+          <a:xfrm>
+            <a:off x="9098279" y="1627632"/>
+            <a:ext cx="2423160" cy="457200"/>
+          </a:xfrm>
+          <a:prstGeom prst="rect">
+            <a:avLst/>
+          </a:prstGeom>
+          <a:noFill/>
+        </p:spPr>
+        <p:txBody>
+          <a:bodyPr wrap="square" lIns="45720" rIns="45720" tIns="18288" bIns="18288">
+            <a:spAutoFit/>
+          </a:bodyPr>
+          <a:lstStyle/>
+          <a:p>
+            <a:pPr algn="l"/>
+            <a:r>
+              <a:rPr sz="2800" b="1" i="0">
+                <a:solidFill>
+                  <a:srgbClr val="1E2761"/>
+                </a:solidFill>
+                <a:latin typeface="Calibri"/>
+              </a:rPr>
+              <a:t>0.97</a:t>
+            </a:r>
+          </a:p>
+        </p:txBody>
+      </p:sp>
+      <p:sp>
+        <p:nvSpPr>
+          <p:cNvPr id="16" name="TextBox 15"/>
+          <p:cNvSpPr txBox="1"/>
+          <p:nvPr/>
+        </p:nvSpPr>
+        <p:spPr>
+          <a:xfrm>
+            <a:off x="9098279" y="2194560"/>
+            <a:ext cx="2423160" cy="365760"/>
+          </a:xfrm>
+          <a:prstGeom prst="rect">
+            <a:avLst/>
+          </a:prstGeom>
+          <a:noFill/>
+        </p:spPr>
+        <p:txBody>
+          <a:bodyPr wrap="square" lIns="45720" rIns="45720" tIns="18288" bIns="18288">
+            <a:spAutoFit/>
+          </a:bodyPr>
+          <a:lstStyle/>
+          <a:p>
+            <a:pPr algn="l"/>
+            <a:r>
+              <a:rPr sz="1100" b="0" i="0">
+                <a:solidFill>
+                  <a:srgbClr val="4B556B"/>
+                </a:solidFill>
+                <a:latin typeface="Calibri"/>
+              </a:rPr>
+              <a:t>Recommender hit-rate (precision@5 +0.08 vs popularity)</a:t>
+            </a:r>
+          </a:p>
+        </p:txBody>
+      </p:sp>
+      <p:pic>
+        <p:nvPicPr>
+          <p:cNvPr id="17" name="Picture 16" descr="fig_confusion.png"/>
+          <p:cNvPicPr>
+            <a:picLocks noChangeAspect="1"/>
+          </p:cNvPicPr>
+          <p:nvPr/>
+        </p:nvPicPr>
+        <p:blipFill>
+          <a:blip r:embed="rId2"/>
+          <a:stretch>
+            <a:fillRect/>
+          </a:stretch>
+        </p:blipFill>
+        <p:spPr>
+          <a:xfrm>
+            <a:off x="1323833" y="3789991"/>
+            <a:ext cx="4118894" cy="1655458"/>
+          </a:xfrm>
+          <a:prstGeom prst="rect">
+            <a:avLst/>
+          </a:prstGeom>
+        </p:spPr>
+      </p:pic>
+      <p:pic>
+        <p:nvPicPr>
+          <p:cNvPr id="18" name="Picture 17" descr="fig_calibration_C.png"/>
+          <p:cNvPicPr>
+            <a:picLocks noChangeAspect="1"/>
+          </p:cNvPicPr>
+          <p:nvPr/>
+        </p:nvPicPr>
+        <p:blipFill>
+          <a:blip r:embed="rId3"/>
+          <a:stretch>
+            <a:fillRect/>
+          </a:stretch>
+        </p:blipFill>
+        <p:spPr>
+          <a:xfrm>
+            <a:off x="6878122" y="3850690"/>
+            <a:ext cx="4257435" cy="1534060"/>
+          </a:xfrm>
+          <a:prstGeom prst="rect">
+            <a:avLst/>
+          </a:prstGeom>
+        </p:spPr>
+      </p:pic>
+      <p:sp>
+        <p:nvSpPr>
+          <p:cNvPr id="19" name="TextBox 18"/>
+          <p:cNvSpPr txBox="1"/>
+          <p:nvPr/>
+        </p:nvSpPr>
+        <p:spPr>
+          <a:xfrm>
+            <a:off x="457200" y="6446520"/>
+            <a:ext cx="7315200" cy="274320"/>
+          </a:xfrm>
+          <a:prstGeom prst="rect">
+            <a:avLst/>
+          </a:prstGeom>
+          <a:noFill/>
+        </p:spPr>
+        <p:txBody>
+          <a:bodyPr wrap="square" lIns="45720" rIns="45720" tIns="18288" bIns="18288">
+            <a:spAutoFit/>
+          </a:bodyPr>
+          <a:lstStyle/>
+          <a:p>
+            <a:pPr algn="l"/>
+            <a:r>
+              <a:rPr sz="900" b="0" i="0">
+                <a:solidFill>
+                  <a:srgbClr val="4B556B"/>
+                </a:solidFill>
+                <a:latin typeface="Calibri"/>
+              </a:rPr>
+              <a:t>COM6003 • Oxford EPC Analysis</a:t>
+            </a:r>
+          </a:p>
+        </p:txBody>
+      </p:sp>
+      <p:sp>
+        <p:nvSpPr>
+          <p:cNvPr id="20" name="TextBox 19"/>
+          <p:cNvSpPr txBox="1"/>
+          <p:nvPr/>
+        </p:nvSpPr>
+        <p:spPr>
+          <a:xfrm>
+            <a:off x="10058400" y="6446520"/>
+            <a:ext cx="1828800" cy="274320"/>
+          </a:xfrm>
+          <a:prstGeom prst="rect">
+            <a:avLst/>
+          </a:prstGeom>
+          <a:noFill/>
+        </p:spPr>
+        <p:txBody>
+          <a:bodyPr wrap="square" lIns="45720" rIns="45720" tIns="18288" bIns="18288">
+            <a:spAutoFit/>
+          </a:bodyPr>
+          <a:lstStyle/>
+          <a:p>
+            <a:pPr algn="r"/>
+            <a:r>
+              <a:rPr sz="900" b="0" i="0">
+                <a:solidFill>
+                  <a:srgbClr val="4B556B"/>
+                </a:solidFill>
+                <a:latin typeface="Calibri"/>
+              </a:rPr>
+              <a:t>12 / 14</a:t>
+            </a:r>
+          </a:p>
+        </p:txBody>
+      </p:sp>
+    </p:spTree>
+  </p:cSld>
+  <p:clrMapOvr>
+    <a:masterClrMapping/>
+  </p:clrMapOvr>
+</p:sld>
+</file>
+
+<file path=ppt/slides/slide13.xml><?xml version="1.0" encoding="utf-8"?>
+<p:sld xmlns:a="http://schemas.openxmlformats.org/drawingml/2006/main" xmlns:p="http://schemas.openxmlformats.org/presentationml/2006/main" xmlns:r="http://schemas.openxmlformats.org/officeDocument/2006/relationships">
+  <p:cSld>
+    <p:spTree>
+      <p:nvGrpSpPr>
+        <p:cNvPr id="1" name=""/>
+        <p:cNvGrpSpPr/>
+        <p:nvPr/>
+      </p:nvGrpSpPr>
+      <p:grpSpPr/>
+      <p:sp>
+        <p:nvSpPr>
+          <p:cNvPr id="2" name="Rectangle 1"/>
+          <p:cNvSpPr/>
+          <p:nvPr/>
+        </p:nvSpPr>
+        <p:spPr>
+          <a:xfrm>
+            <a:off x="0" y="0"/>
+            <a:ext cx="164592" cy="6858000"/>
+          </a:xfrm>
+          <a:prstGeom prst="rect">
+            <a:avLst/>
+          </a:prstGeom>
+          <a:solidFill>
+            <a:srgbClr val="1E2761"/>
+          </a:solidFill>
+          <a:ln>
+            <a:noFill/>
+          </a:ln>
+        </p:spPr>
+        <p:style>
+          <a:lnRef idx="1">
+            <a:schemeClr val="accent1"/>
+          </a:lnRef>
+          <a:fillRef idx="3">
+            <a:schemeClr val="accent1"/>
+          </a:fillRef>
+          <a:effectRef idx="2">
+            <a:schemeClr val="accent1"/>
+          </a:effectRef>
+          <a:fontRef idx="minor">
+            <a:schemeClr val="lt1"/>
+          </a:fontRef>
+        </p:style>
+        <p:txBody>
+          <a:bodyPr rtlCol="0" anchor="ctr"/>
+          <a:lstStyle/>
+          <a:p>
+            <a:pPr algn="ctr"/>
+          </a:p>
+        </p:txBody>
+      </p:sp>
+      <p:sp>
+        <p:nvSpPr>
+          <p:cNvPr id="3" name="TextBox 2"/>
+          <p:cNvSpPr txBox="1"/>
+          <p:nvPr/>
+        </p:nvSpPr>
+        <p:spPr>
+          <a:xfrm>
+            <a:off x="502920" y="292608"/>
+            <a:ext cx="10972800" cy="640080"/>
+          </a:xfrm>
+          <a:prstGeom prst="rect">
+            <a:avLst/>
+          </a:prstGeom>
+          <a:noFill/>
+        </p:spPr>
+        <p:txBody>
+          <a:bodyPr wrap="square" lIns="45720" rIns="45720" tIns="18288" bIns="18288">
+            <a:spAutoFit/>
+          </a:bodyPr>
+          <a:lstStyle/>
+          <a:p>
+            <a:pPr algn="l"/>
+            <a:r>
+              <a:rPr sz="3000" b="1" i="0">
+                <a:solidFill>
+                  <a:srgbClr val="1E2761"/>
+                </a:solidFill>
+                <a:latin typeface="Calibri"/>
+              </a:rPr>
+              <a:t>Recommendations</a:t>
+            </a:r>
+          </a:p>
+        </p:txBody>
+      </p:sp>
+      <p:sp>
+        <p:nvSpPr>
+          <p:cNvPr id="4" name="TextBox 3"/>
+          <p:cNvSpPr txBox="1"/>
+          <p:nvPr/>
+        </p:nvSpPr>
+        <p:spPr>
+          <a:xfrm>
+            <a:off x="502920" y="868680"/>
+            <a:ext cx="10972800" cy="365760"/>
+          </a:xfrm>
+          <a:prstGeom prst="rect">
+            <a:avLst/>
+          </a:prstGeom>
+          <a:noFill/>
+        </p:spPr>
+        <p:txBody>
+          <a:bodyPr wrap="square" lIns="45720" rIns="45720" tIns="18288" bIns="18288">
+            <a:spAutoFit/>
+          </a:bodyPr>
+          <a:lstStyle/>
+          <a:p>
+            <a:pPr algn="l"/>
+            <a:r>
+              <a:rPr sz="1400" b="0" i="1">
+                <a:solidFill>
+                  <a:srgbClr val="4B556B"/>
+                </a:solidFill>
+                <a:latin typeface="Calibri"/>
+              </a:rPr>
+              <a:t>For Oxford City Council and registered providers</a:t>
+            </a:r>
+          </a:p>
+        </p:txBody>
+      </p:sp>
+      <p:sp>
+        <p:nvSpPr>
+          <p:cNvPr id="5" name="Oval 4"/>
+          <p:cNvSpPr/>
+          <p:nvPr/>
+        </p:nvSpPr>
+        <p:spPr>
+          <a:xfrm>
+            <a:off x="640080" y="1554480"/>
+            <a:ext cx="640080" cy="640080"/>
+          </a:xfrm>
+          <a:prstGeom prst="ellipse">
+            <a:avLst/>
+          </a:prstGeom>
+          <a:solidFill>
+            <a:srgbClr val="F9C177"/>
+          </a:solidFill>
+          <a:ln>
+            <a:noFill/>
+          </a:ln>
+        </p:spPr>
+        <p:style>
+          <a:lnRef idx="1">
+            <a:schemeClr val="accent1"/>
+          </a:lnRef>
+          <a:fillRef idx="3">
+            <a:schemeClr val="accent1"/>
+          </a:fillRef>
+          <a:effectRef idx="2">
+            <a:schemeClr val="accent1"/>
+          </a:effectRef>
+          <a:fontRef idx="minor">
+            <a:schemeClr val="lt1"/>
+          </a:fontRef>
+        </p:style>
+        <p:txBody>
+          <a:bodyPr rtlCol="0" anchor="ctr"/>
+          <a:lstStyle/>
+          <a:p>
+            <a:pPr algn="ctr"/>
+          </a:p>
+        </p:txBody>
+      </p:sp>
+      <p:sp>
+        <p:nvSpPr>
+          <p:cNvPr id="6" name="TextBox 5"/>
+          <p:cNvSpPr txBox="1"/>
+          <p:nvPr/>
+        </p:nvSpPr>
+        <p:spPr>
+          <a:xfrm>
+            <a:off x="640080" y="1645920"/>
+            <a:ext cx="640080" cy="457200"/>
+          </a:xfrm>
+          <a:prstGeom prst="rect">
+            <a:avLst/>
+          </a:prstGeom>
+          <a:noFill/>
+        </p:spPr>
+        <p:txBody>
+          <a:bodyPr wrap="square" lIns="45720" rIns="45720" tIns="18288" bIns="18288">
+            <a:spAutoFit/>
+          </a:bodyPr>
+          <a:lstStyle/>
+          <a:p>
+            <a:pPr algn="ctr"/>
+            <a:r>
+              <a:rPr sz="1800" b="1" i="0">
+                <a:solidFill>
+                  <a:srgbClr val="1E2761"/>
+                </a:solidFill>
+                <a:latin typeface="Calibri"/>
+              </a:rPr>
+              <a:t>1.</a:t>
+            </a:r>
+          </a:p>
+        </p:txBody>
+      </p:sp>
+      <p:sp>
+        <p:nvSpPr>
+          <p:cNvPr id="7" name="TextBox 6"/>
+          <p:cNvSpPr txBox="1"/>
+          <p:nvPr/>
+        </p:nvSpPr>
+        <p:spPr>
+          <a:xfrm>
+            <a:off x="1463040" y="1600200"/>
+            <a:ext cx="10515600" cy="411480"/>
+          </a:xfrm>
+          <a:prstGeom prst="rect">
+            <a:avLst/>
+          </a:prstGeom>
+          <a:noFill/>
+        </p:spPr>
+        <p:txBody>
+          <a:bodyPr wrap="square" lIns="45720" rIns="45720" tIns="18288" bIns="18288">
+            <a:spAutoFit/>
+          </a:bodyPr>
+          <a:lstStyle/>
+          <a:p>
+            <a:pPr algn="l"/>
+            <a:r>
+              <a:rPr sz="1800" b="1" i="0">
+                <a:solidFill>
+                  <a:srgbClr val="1E2761"/>
+                </a:solidFill>
+                <a:latin typeface="Calibri"/>
+              </a:rPr>
+              <a:t>Solid-wall insulation in pre-1929 stock</a:t>
+            </a:r>
+          </a:p>
+        </p:txBody>
+      </p:sp>
+      <p:sp>
+        <p:nvSpPr>
+          <p:cNvPr id="8" name="TextBox 7"/>
+          <p:cNvSpPr txBox="1"/>
+          <p:nvPr/>
+        </p:nvSpPr>
+        <p:spPr>
+          <a:xfrm>
+            <a:off x="1463040" y="2011680"/>
+            <a:ext cx="10515600" cy="457200"/>
+          </a:xfrm>
+          <a:prstGeom prst="rect">
+            <a:avLst/>
+          </a:prstGeom>
+          <a:noFill/>
+        </p:spPr>
+        <p:txBody>
+          <a:bodyPr wrap="square" lIns="45720" rIns="45720" tIns="18288" bIns="18288">
+            <a:spAutoFit/>
+          </a:bodyPr>
+          <a:lstStyle/>
+          <a:p>
+            <a:pPr algn="l"/>
+            <a:r>
+              <a:rPr sz="1200" b="0" i="0">
+                <a:solidFill>
+                  <a:srgbClr val="4B556B"/>
+                </a:solidFill>
+                <a:latin typeface="Calibri"/>
+              </a:rPr>
+              <a:t>Largest single physical lever; £4-14k per dwelling; SAP-engine corroborates.</a:t>
+            </a:r>
+          </a:p>
+        </p:txBody>
+      </p:sp>
+      <p:sp>
+        <p:nvSpPr>
+          <p:cNvPr id="9" name="Oval 8"/>
+          <p:cNvSpPr/>
+          <p:nvPr/>
+        </p:nvSpPr>
+        <p:spPr>
+          <a:xfrm>
+            <a:off x="640080" y="2514600"/>
+            <a:ext cx="640080" cy="640080"/>
+          </a:xfrm>
+          <a:prstGeom prst="ellipse">
+            <a:avLst/>
+          </a:prstGeom>
+          <a:solidFill>
+            <a:srgbClr val="F9C177"/>
+          </a:solidFill>
+          <a:ln>
+            <a:noFill/>
+          </a:ln>
+        </p:spPr>
+        <p:style>
+          <a:lnRef idx="1">
+            <a:schemeClr val="accent1"/>
+          </a:lnRef>
+          <a:fillRef idx="3">
+            <a:schemeClr val="accent1"/>
+          </a:fillRef>
+          <a:effectRef idx="2">
+            <a:schemeClr val="accent1"/>
+          </a:effectRef>
+          <a:fontRef idx="minor">
+            <a:schemeClr val="lt1"/>
+          </a:fontRef>
+        </p:style>
+        <p:txBody>
+          <a:bodyPr rtlCol="0" anchor="ctr"/>
+          <a:lstStyle/>
+          <a:p>
+            <a:pPr algn="ctr"/>
+          </a:p>
+        </p:txBody>
+      </p:sp>
+      <p:sp>
+        <p:nvSpPr>
+          <p:cNvPr id="10" name="TextBox 9"/>
+          <p:cNvSpPr txBox="1"/>
+          <p:nvPr/>
+        </p:nvSpPr>
+        <p:spPr>
+          <a:xfrm>
+            <a:off x="640080" y="2606040"/>
+            <a:ext cx="640080" cy="457200"/>
+          </a:xfrm>
+          <a:prstGeom prst="rect">
+            <a:avLst/>
+          </a:prstGeom>
+          <a:noFill/>
+        </p:spPr>
+        <p:txBody>
+          <a:bodyPr wrap="square" lIns="45720" rIns="45720" tIns="18288" bIns="18288">
+            <a:spAutoFit/>
+          </a:bodyPr>
+          <a:lstStyle/>
+          <a:p>
+            <a:pPr algn="ctr"/>
+            <a:r>
+              <a:rPr sz="1800" b="1" i="0">
+                <a:solidFill>
+                  <a:srgbClr val="1E2761"/>
+                </a:solidFill>
+                <a:latin typeface="Calibri"/>
+              </a:rPr>
+              <a:t>2.</a:t>
+            </a:r>
+          </a:p>
+        </p:txBody>
+      </p:sp>
+      <p:sp>
+        <p:nvSpPr>
+          <p:cNvPr id="11" name="TextBox 10"/>
+          <p:cNvSpPr txBox="1"/>
+          <p:nvPr/>
+        </p:nvSpPr>
+        <p:spPr>
+          <a:xfrm>
+            <a:off x="1463040" y="2560320"/>
+            <a:ext cx="10515600" cy="411480"/>
+          </a:xfrm>
+          <a:prstGeom prst="rect">
+            <a:avLst/>
+          </a:prstGeom>
+          <a:noFill/>
+        </p:spPr>
+        <p:txBody>
+          <a:bodyPr wrap="square" lIns="45720" rIns="45720" tIns="18288" bIns="18288">
+            <a:spAutoFit/>
+          </a:bodyPr>
+          <a:lstStyle/>
+          <a:p>
+            <a:pPr algn="l"/>
+            <a:r>
+              <a:rPr sz="1800" b="1" i="0">
+                <a:solidFill>
+                  <a:srgbClr val="1E2761"/>
+                </a:solidFill>
+                <a:latin typeface="Calibri"/>
+              </a:rPr>
+              <a:t>Loft insulation top-ups to ≥ 270 mm</a:t>
+            </a:r>
+          </a:p>
+        </p:txBody>
+      </p:sp>
+      <p:sp>
+        <p:nvSpPr>
+          <p:cNvPr id="12" name="TextBox 11"/>
+          <p:cNvSpPr txBox="1"/>
+          <p:nvPr/>
+        </p:nvSpPr>
+        <p:spPr>
+          <a:xfrm>
+            <a:off x="1463040" y="2971800"/>
+            <a:ext cx="10515600" cy="457200"/>
+          </a:xfrm>
+          <a:prstGeom prst="rect">
+            <a:avLst/>
+          </a:prstGeom>
+          <a:noFill/>
+        </p:spPr>
+        <p:txBody>
+          <a:bodyPr wrap="square" lIns="45720" rIns="45720" tIns="18288" bIns="18288">
+            <a:spAutoFit/>
+          </a:bodyPr>
+          <a:lstStyle/>
+          <a:p>
+            <a:pPr algn="l"/>
+            <a:r>
+              <a:rPr sz="1200" b="0" i="0">
+                <a:solidFill>
+                  <a:srgbClr val="4B556B"/>
+                </a:solidFill>
+                <a:latin typeface="Calibri"/>
+              </a:rPr>
+              <a:t>Cheapest material intervention; positive SHAP across nearly all bands.</a:t>
+            </a:r>
+          </a:p>
+        </p:txBody>
+      </p:sp>
+      <p:sp>
+        <p:nvSpPr>
+          <p:cNvPr id="13" name="Oval 12"/>
+          <p:cNvSpPr/>
+          <p:nvPr/>
+        </p:nvSpPr>
+        <p:spPr>
+          <a:xfrm>
+            <a:off x="640080" y="3474720"/>
+            <a:ext cx="640080" cy="640080"/>
+          </a:xfrm>
+          <a:prstGeom prst="ellipse">
+            <a:avLst/>
+          </a:prstGeom>
+          <a:solidFill>
+            <a:srgbClr val="F9C177"/>
+          </a:solidFill>
+          <a:ln>
+            <a:noFill/>
+          </a:ln>
+        </p:spPr>
+        <p:style>
+          <a:lnRef idx="1">
+            <a:schemeClr val="accent1"/>
+          </a:lnRef>
+          <a:fillRef idx="3">
+            <a:schemeClr val="accent1"/>
+          </a:fillRef>
+          <a:effectRef idx="2">
+            <a:schemeClr val="accent1"/>
+          </a:effectRef>
+          <a:fontRef idx="minor">
+            <a:schemeClr val="lt1"/>
+          </a:fontRef>
+        </p:style>
+        <p:txBody>
+          <a:bodyPr rtlCol="0" anchor="ctr"/>
+          <a:lstStyle/>
+          <a:p>
+            <a:pPr algn="ctr"/>
+          </a:p>
+        </p:txBody>
+      </p:sp>
+      <p:sp>
+        <p:nvSpPr>
+          <p:cNvPr id="14" name="TextBox 13"/>
+          <p:cNvSpPr txBox="1"/>
+          <p:nvPr/>
+        </p:nvSpPr>
+        <p:spPr>
+          <a:xfrm>
+            <a:off x="640080" y="3566160"/>
+            <a:ext cx="640080" cy="457200"/>
+          </a:xfrm>
+          <a:prstGeom prst="rect">
+            <a:avLst/>
+          </a:prstGeom>
+          <a:noFill/>
+        </p:spPr>
+        <p:txBody>
+          <a:bodyPr wrap="square" lIns="45720" rIns="45720" tIns="18288" bIns="18288">
+            <a:spAutoFit/>
+          </a:bodyPr>
+          <a:lstStyle/>
+          <a:p>
+            <a:pPr algn="ctr"/>
+            <a:r>
+              <a:rPr sz="1800" b="1" i="0">
+                <a:solidFill>
+                  <a:srgbClr val="1E2761"/>
+                </a:solidFill>
+                <a:latin typeface="Calibri"/>
+              </a:rPr>
+              <a:t>3.</a:t>
+            </a:r>
+          </a:p>
+        </p:txBody>
+      </p:sp>
+      <p:sp>
+        <p:nvSpPr>
+          <p:cNvPr id="15" name="TextBox 14"/>
+          <p:cNvSpPr txBox="1"/>
+          <p:nvPr/>
+        </p:nvSpPr>
+        <p:spPr>
+          <a:xfrm>
+            <a:off x="1463040" y="3520440"/>
+            <a:ext cx="10515600" cy="411480"/>
+          </a:xfrm>
+          <a:prstGeom prst="rect">
+            <a:avLst/>
+          </a:prstGeom>
+          <a:noFill/>
+        </p:spPr>
+        <p:txBody>
+          <a:bodyPr wrap="square" lIns="45720" rIns="45720" tIns="18288" bIns="18288">
+            <a:spAutoFit/>
+          </a:bodyPr>
+          <a:lstStyle/>
+          <a:p>
+            <a:pPr algn="l"/>
+            <a:r>
+              <a:rPr sz="1800" b="1" i="0">
+                <a:solidFill>
+                  <a:srgbClr val="1E2761"/>
+                </a:solidFill>
+                <a:latin typeface="Calibri"/>
+              </a:rPr>
+              <a:t>Replace single glazing in 1900-1949 cohort</a:t>
+            </a:r>
+          </a:p>
+        </p:txBody>
+      </p:sp>
+      <p:sp>
+        <p:nvSpPr>
+          <p:cNvPr id="16" name="TextBox 15"/>
+          <p:cNvSpPr txBox="1"/>
+          <p:nvPr/>
+        </p:nvSpPr>
+        <p:spPr>
+          <a:xfrm>
+            <a:off x="1463040" y="3931920"/>
+            <a:ext cx="10515600" cy="457200"/>
+          </a:xfrm>
+          <a:prstGeom prst="rect">
+            <a:avLst/>
+          </a:prstGeom>
+          <a:noFill/>
+        </p:spPr>
+        <p:txBody>
+          <a:bodyPr wrap="square" lIns="45720" rIns="45720" tIns="18288" bIns="18288">
+            <a:spAutoFit/>
+          </a:bodyPr>
+          <a:lstStyle/>
+          <a:p>
+            <a:pPr algn="l"/>
+            <a:r>
+              <a:rPr sz="1200" b="0" i="0">
+                <a:solidFill>
+                  <a:srgbClr val="4B556B"/>
+                </a:solidFill>
+                <a:latin typeface="Calibri"/>
+              </a:rPr>
+              <a:t>Concentration of FLAG_SINGLE_GLAZED; immediate comfort benefit.</a:t>
+            </a:r>
+          </a:p>
+        </p:txBody>
+      </p:sp>
+      <p:sp>
+        <p:nvSpPr>
+          <p:cNvPr id="17" name="Oval 16"/>
+          <p:cNvSpPr/>
+          <p:nvPr/>
+        </p:nvSpPr>
+        <p:spPr>
+          <a:xfrm>
+            <a:off x="640080" y="4434840"/>
+            <a:ext cx="640080" cy="640080"/>
+          </a:xfrm>
+          <a:prstGeom prst="ellipse">
+            <a:avLst/>
+          </a:prstGeom>
+          <a:solidFill>
+            <a:srgbClr val="F9C177"/>
+          </a:solidFill>
+          <a:ln>
+            <a:noFill/>
+          </a:ln>
+        </p:spPr>
+        <p:style>
+          <a:lnRef idx="1">
+            <a:schemeClr val="accent1"/>
+          </a:lnRef>
+          <a:fillRef idx="3">
+            <a:schemeClr val="accent1"/>
+          </a:fillRef>
+          <a:effectRef idx="2">
+            <a:schemeClr val="accent1"/>
+          </a:effectRef>
+          <a:fontRef idx="minor">
+            <a:schemeClr val="lt1"/>
+          </a:fontRef>
+        </p:style>
+        <p:txBody>
+          <a:bodyPr rtlCol="0" anchor="ctr"/>
+          <a:lstStyle/>
+          <a:p>
+            <a:pPr algn="ctr"/>
+          </a:p>
+        </p:txBody>
+      </p:sp>
+      <p:sp>
+        <p:nvSpPr>
+          <p:cNvPr id="18" name="TextBox 17"/>
+          <p:cNvSpPr txBox="1"/>
+          <p:nvPr/>
+        </p:nvSpPr>
+        <p:spPr>
+          <a:xfrm>
+            <a:off x="640080" y="4526280"/>
+            <a:ext cx="640080" cy="457200"/>
+          </a:xfrm>
+          <a:prstGeom prst="rect">
+            <a:avLst/>
+          </a:prstGeom>
+          <a:noFill/>
+        </p:spPr>
+        <p:txBody>
+          <a:bodyPr wrap="square" lIns="45720" rIns="45720" tIns="18288" bIns="18288">
+            <a:spAutoFit/>
+          </a:bodyPr>
+          <a:lstStyle/>
+          <a:p>
+            <a:pPr algn="ctr"/>
+            <a:r>
+              <a:rPr sz="1800" b="1" i="0">
+                <a:solidFill>
+                  <a:srgbClr val="1E2761"/>
+                </a:solidFill>
+                <a:latin typeface="Calibri"/>
+              </a:rPr>
+              <a:t>4.</a:t>
+            </a:r>
+          </a:p>
+        </p:txBody>
+      </p:sp>
+      <p:sp>
+        <p:nvSpPr>
+          <p:cNvPr id="19" name="TextBox 18"/>
+          <p:cNvSpPr txBox="1"/>
+          <p:nvPr/>
+        </p:nvSpPr>
+        <p:spPr>
+          <a:xfrm>
+            <a:off x="1463040" y="4480560"/>
+            <a:ext cx="10515600" cy="411480"/>
+          </a:xfrm>
+          <a:prstGeom prst="rect">
+            <a:avLst/>
+          </a:prstGeom>
+          <a:noFill/>
+        </p:spPr>
+        <p:txBody>
+          <a:bodyPr wrap="square" lIns="45720" rIns="45720" tIns="18288" bIns="18288">
+            <a:spAutoFit/>
+          </a:bodyPr>
+          <a:lstStyle/>
+          <a:p>
+            <a:pPr algn="l"/>
+            <a:r>
+              <a:rPr sz="1800" b="1" i="0">
+                <a:solidFill>
+                  <a:srgbClr val="1E2761"/>
+                </a:solidFill>
+                <a:latin typeface="Calibri"/>
+              </a:rPr>
+              <a:t>Communicate the heat-pump SAP caveat</a:t>
+            </a:r>
+          </a:p>
+        </p:txBody>
+      </p:sp>
+      <p:sp>
+        <p:nvSpPr>
+          <p:cNvPr id="20" name="TextBox 19"/>
+          <p:cNvSpPr txBox="1"/>
+          <p:nvPr/>
+        </p:nvSpPr>
+        <p:spPr>
+          <a:xfrm>
+            <a:off x="1463040" y="4892040"/>
+            <a:ext cx="10515600" cy="457200"/>
+          </a:xfrm>
+          <a:prstGeom prst="rect">
+            <a:avLst/>
+          </a:prstGeom>
+          <a:noFill/>
+        </p:spPr>
+        <p:txBody>
+          <a:bodyPr wrap="square" lIns="45720" rIns="45720" tIns="18288" bIns="18288">
+            <a:spAutoFit/>
+          </a:bodyPr>
+          <a:lstStyle/>
+          <a:p>
+            <a:pPr algn="l"/>
+            <a:r>
+              <a:rPr sz="1200" b="0" i="0">
+                <a:solidFill>
+                  <a:srgbClr val="4B556B"/>
+                </a:solidFill>
+                <a:latin typeface="Calibri"/>
+              </a:rPr>
+              <a:t>SAP is cost-based; tariff differential blunts rating gain: manage expectations.</a:t>
+            </a:r>
+          </a:p>
+        </p:txBody>
+      </p:sp>
+      <p:sp>
+        <p:nvSpPr>
+          <p:cNvPr id="21" name="Oval 20"/>
+          <p:cNvSpPr/>
+          <p:nvPr/>
+        </p:nvSpPr>
+        <p:spPr>
+          <a:xfrm>
+            <a:off x="640080" y="5394960"/>
+            <a:ext cx="640080" cy="640080"/>
+          </a:xfrm>
+          <a:prstGeom prst="ellipse">
+            <a:avLst/>
+          </a:prstGeom>
+          <a:solidFill>
+            <a:srgbClr val="F9C177"/>
+          </a:solidFill>
+          <a:ln>
+            <a:noFill/>
+          </a:ln>
+        </p:spPr>
+        <p:style>
+          <a:lnRef idx="1">
+            <a:schemeClr val="accent1"/>
+          </a:lnRef>
+          <a:fillRef idx="3">
+            <a:schemeClr val="accent1"/>
+          </a:fillRef>
+          <a:effectRef idx="2">
+            <a:schemeClr val="accent1"/>
+          </a:effectRef>
+          <a:fontRef idx="minor">
+            <a:schemeClr val="lt1"/>
+          </a:fontRef>
+        </p:style>
+        <p:txBody>
+          <a:bodyPr rtlCol="0" anchor="ctr"/>
+          <a:lstStyle/>
+          <a:p>
+            <a:pPr algn="ctr"/>
+          </a:p>
+        </p:txBody>
+      </p:sp>
+      <p:sp>
+        <p:nvSpPr>
+          <p:cNvPr id="22" name="TextBox 21"/>
+          <p:cNvSpPr txBox="1"/>
+          <p:nvPr/>
+        </p:nvSpPr>
+        <p:spPr>
+          <a:xfrm>
+            <a:off x="640080" y="5486400"/>
+            <a:ext cx="640080" cy="457200"/>
+          </a:xfrm>
+          <a:prstGeom prst="rect">
+            <a:avLst/>
+          </a:prstGeom>
+          <a:noFill/>
+        </p:spPr>
+        <p:txBody>
+          <a:bodyPr wrap="square" lIns="45720" rIns="45720" tIns="18288" bIns="18288">
+            <a:spAutoFit/>
+          </a:bodyPr>
+          <a:lstStyle/>
+          <a:p>
+            <a:pPr algn="ctr"/>
+            <a:r>
+              <a:rPr sz="1800" b="1" i="0">
+                <a:solidFill>
+                  <a:srgbClr val="1E2761"/>
+                </a:solidFill>
+                <a:latin typeface="Calibri"/>
+              </a:rPr>
+              <a:t>5.</a:t>
+            </a:r>
+          </a:p>
+        </p:txBody>
+      </p:sp>
+      <p:sp>
+        <p:nvSpPr>
+          <p:cNvPr id="23" name="TextBox 22"/>
+          <p:cNvSpPr txBox="1"/>
+          <p:nvPr/>
+        </p:nvSpPr>
+        <p:spPr>
+          <a:xfrm>
+            <a:off x="1463040" y="5440680"/>
+            <a:ext cx="10515600" cy="411480"/>
+          </a:xfrm>
+          <a:prstGeom prst="rect">
+            <a:avLst/>
+          </a:prstGeom>
+          <a:noFill/>
+        </p:spPr>
+        <p:txBody>
+          <a:bodyPr wrap="square" lIns="45720" rIns="45720" tIns="18288" bIns="18288">
+            <a:spAutoFit/>
+          </a:bodyPr>
+          <a:lstStyle/>
+          <a:p>
+            <a:pPr algn="l"/>
+            <a:r>
+              <a:rPr sz="1800" b="1" i="0">
+                <a:solidFill>
+                  <a:srgbClr val="1E2761"/>
+                </a:solidFill>
+                <a:latin typeface="Calibri"/>
+              </a:rPr>
+              <a:t>Geographic targeting: OX1 / OX2 / OX4</a:t>
+            </a:r>
+          </a:p>
+        </p:txBody>
+      </p:sp>
+      <p:sp>
+        <p:nvSpPr>
+          <p:cNvPr id="24" name="TextBox 23"/>
+          <p:cNvSpPr txBox="1"/>
+          <p:nvPr/>
+        </p:nvSpPr>
+        <p:spPr>
+          <a:xfrm>
+            <a:off x="1463040" y="5852160"/>
+            <a:ext cx="10515600" cy="457200"/>
+          </a:xfrm>
+          <a:prstGeom prst="rect">
+            <a:avLst/>
+          </a:prstGeom>
+          <a:noFill/>
+        </p:spPr>
+        <p:txBody>
+          <a:bodyPr wrap="square" lIns="45720" rIns="45720" tIns="18288" bIns="18288">
+            <a:spAutoFit/>
+          </a:bodyPr>
+          <a:lstStyle/>
+          <a:p>
+            <a:pPr algn="l"/>
+            <a:r>
+              <a:rPr sz="1200" b="0" i="0">
+                <a:solidFill>
+                  <a:srgbClr val="4B556B"/>
+                </a:solidFill>
+                <a:latin typeface="Calibri"/>
+              </a:rPr>
+              <a:t>Highest density of pre-1900 stock; district-weighted subsidies. Operational deliverable: reports/predictions_oxford.csv (76,400 per-UPRN predictions + confidence proxy).</a:t>
+            </a:r>
+          </a:p>
+        </p:txBody>
+      </p:sp>
+      <p:sp>
+        <p:nvSpPr>
+          <p:cNvPr id="25" name="TextBox 24"/>
+          <p:cNvSpPr txBox="1"/>
+          <p:nvPr/>
+        </p:nvSpPr>
+        <p:spPr>
+          <a:xfrm>
+            <a:off x="457200" y="6446520"/>
+            <a:ext cx="7315200" cy="274320"/>
+          </a:xfrm>
+          <a:prstGeom prst="rect">
+            <a:avLst/>
+          </a:prstGeom>
+          <a:noFill/>
+        </p:spPr>
+        <p:txBody>
+          <a:bodyPr wrap="square" lIns="45720" rIns="45720" tIns="18288" bIns="18288">
+            <a:spAutoFit/>
+          </a:bodyPr>
+          <a:lstStyle/>
+          <a:p>
+            <a:pPr algn="l"/>
+            <a:r>
+              <a:rPr sz="900" b="0" i="0">
+                <a:solidFill>
+                  <a:srgbClr val="4B556B"/>
+                </a:solidFill>
+                <a:latin typeface="Calibri"/>
+              </a:rPr>
+              <a:t>COM6003 • Oxford EPC Analysis</a:t>
+            </a:r>
+          </a:p>
+        </p:txBody>
+      </p:sp>
+      <p:sp>
+        <p:nvSpPr>
+          <p:cNvPr id="26" name="TextBox 25"/>
+          <p:cNvSpPr txBox="1"/>
+          <p:nvPr/>
+        </p:nvSpPr>
+        <p:spPr>
+          <a:xfrm>
+            <a:off x="10058400" y="6446520"/>
+            <a:ext cx="1828800" cy="274320"/>
+          </a:xfrm>
+          <a:prstGeom prst="rect">
+            <a:avLst/>
+          </a:prstGeom>
+          <a:noFill/>
+        </p:spPr>
+        <p:txBody>
+          <a:bodyPr wrap="square" lIns="45720" rIns="45720" tIns="18288" bIns="18288">
+            <a:spAutoFit/>
+          </a:bodyPr>
+          <a:lstStyle/>
+          <a:p>
+            <a:pPr algn="r"/>
+            <a:r>
+              <a:rPr sz="900" b="0" i="0">
+                <a:solidFill>
+                  <a:srgbClr val="4B556B"/>
+                </a:solidFill>
+                <a:latin typeface="Calibri"/>
+              </a:rPr>
+              <a:t>13 / 14</a:t>
+            </a:r>
+          </a:p>
+        </p:txBody>
+      </p:sp>
+    </p:spTree>
+  </p:cSld>
+  <p:clrMapOvr>
+    <a:masterClrMapping/>
+  </p:clrMapOvr>
+</p:sld>
+</file>
+
+<file path=ppt/slides/slide14.xml><?xml version="1.0" encoding="utf-8"?>
+<p:sld xmlns:a="http://schemas.openxmlformats.org/drawingml/2006/main" xmlns:p="http://schemas.openxmlformats.org/presentationml/2006/main" xmlns:r="http://schemas.openxmlformats.org/officeDocument/2006/relationships">
+  <p:cSld>
+    <p:spTree>
+      <p:nvGrpSpPr>
+        <p:cNvPr id="1" name=""/>
+        <p:cNvGrpSpPr/>
+        <p:nvPr/>
+      </p:nvGrpSpPr>
+      <p:grpSpPr/>
+      <p:sp>
+        <p:nvSpPr>
+          <p:cNvPr id="2" name="Rectangle 1"/>
+          <p:cNvSpPr/>
+          <p:nvPr/>
+        </p:nvSpPr>
+        <p:spPr>
+          <a:xfrm>
+            <a:off x="0" y="0"/>
+            <a:ext cx="12191695" cy="6858000"/>
+          </a:xfrm>
+          <a:prstGeom prst="rect">
+            <a:avLst/>
+          </a:prstGeom>
+          <a:solidFill>
+            <a:srgbClr val="1E2761"/>
+          </a:solidFill>
+          <a:ln>
+            <a:noFill/>
+          </a:ln>
+        </p:spPr>
+        <p:style>
+          <a:lnRef idx="1">
+            <a:schemeClr val="accent1"/>
+          </a:lnRef>
+          <a:fillRef idx="3">
+            <a:schemeClr val="accent1"/>
+          </a:fillRef>
+          <a:effectRef idx="2">
+            <a:schemeClr val="accent1"/>
+          </a:effectRef>
+          <a:fontRef idx="minor">
+            <a:schemeClr val="lt1"/>
+          </a:fontRef>
+        </p:style>
+        <p:txBody>
+          <a:bodyPr rtlCol="0" anchor="ctr"/>
+          <a:lstStyle/>
+          <a:p>
+            <a:pPr algn="ctr"/>
+          </a:p>
+        </p:txBody>
+      </p:sp>
+      <p:sp>
+        <p:nvSpPr>
+          <p:cNvPr id="3" name="TextBox 2"/>
+          <p:cNvSpPr txBox="1"/>
+          <p:nvPr/>
+        </p:nvSpPr>
+        <p:spPr>
+          <a:xfrm>
             <a:off x="640080" y="548640"/>
             <a:ext cx="10972800" cy="640080"/>
           </a:xfrm>
@@ -4755,7 +6175,7 @@
                 </a:solidFill>
                 <a:latin typeface="Calibri"/>
               </a:rPr>
-              <a:t>Honest about the ceiling — not all variance is reducible</a:t>
+              <a:t>Honest about the ceiling: not all variance is reducible</a:t>
             </a:r>
           </a:p>
         </p:txBody>
@@ -4829,7 +6249,7 @@
                 </a:solidFill>
                 <a:latin typeface="Calibri"/>
               </a:rPr>
-              <a:t>•  RdSAP is modelled, not measured — assessor variance ≈ ±5 SAP points (Few et al., 2023; Hardy and Glew, 2019). Our score MAE = 4.05 is at the irreducible label-noise floor.</a:t>
+              <a:t>•  RdSAP is modelled, not measured: assessor variance ≈ ±5 SAP points (Few et al., 2023; Hardy and Glew, 2019). Our score MAE = 4.05 is at the irreducible label-noise floor.</a:t>
             </a:r>
           </a:p>
           <a:p>
@@ -4877,7 +6297,7 @@
                 </a:solidFill>
                 <a:latin typeface="Calibri"/>
               </a:rPr>
-              <a:t>•  rt_101 (SAP) cohort holdout QWK = 0.563 despite the hybrid lift — SAP-score predictions cluster near band boundaries (99.2% within 15 SAP pts).</a:t>
+              <a:t>•  rt_101 (SAP) cohort holdout QWK = 0.578 despite the hybrid lift: SAP-score predictions cluster near band boundaries (98.8% within 15 SAP pts).</a:t>
             </a:r>
           </a:p>
           <a:p>
@@ -4893,7 +6313,7 @@
                 </a:solidFill>
                 <a:latin typeface="Calibri"/>
               </a:rPr>
-              <a:t>•  Findings calibrated to Oxford's pre-1900-heavy stock — do not extrapolate unmodified.</a:t>
+              <a:t>•  Findings calibrated to Oxford's pre-1900-heavy stock: do not extrapolate unmodified.</a:t>
             </a:r>
           </a:p>
           <a:p>
@@ -5146,7 +6566,7 @@
                 </a:solidFill>
                 <a:latin typeface="Calibri"/>
               </a:rPr>
-              <a:t>•  Oxford: 30.4% of dwellings built before 1900 — almost double the England-wide share (ONS, 2023).</a:t>
+              <a:t>•  Oxford: 30.4% of dwellings built before 1900: almost double the England-wide share (ONS, 2023).</a:t>
             </a:r>
           </a:p>
           <a:p>
@@ -5542,7 +6962,7 @@
                 </a:solidFill>
                 <a:latin typeface="Calibri"/>
               </a:rPr>
-              <a:t>COM6003 — Oxford EPC Analysis</a:t>
+              <a:t>COM6003 • Oxford EPC Analysis</a:t>
             </a:r>
           </a:p>
         </p:txBody>
@@ -5577,7 +6997,7 @@
                 </a:solidFill>
                 <a:latin typeface="Calibri"/>
               </a:rPr>
-              <a:t>2 / 12</a:t>
+              <a:t>2 / 14</a:t>
             </a:r>
           </a:p>
         </p:txBody>
@@ -5708,7 +7128,7 @@
                 </a:solidFill>
                 <a:latin typeface="Calibri"/>
               </a:rPr>
-              <a:t>Energy Performance of Buildings Register — Oxford (E07000178)</a:t>
+              <a:t>Energy Performance of Buildings Register: Oxford (E07000178)</a:t>
             </a:r>
           </a:p>
         </p:txBody>
@@ -5779,7 +7199,7 @@
                 </a:solidFill>
                 <a:latin typeface="Calibri"/>
               </a:rPr>
-              <a:t>•  After cleaning + dedup-per-UPRN: 49420 certificates.</a:t>
+              <a:t>•  After cleaning + dedup-per-UPRN: 49,442 certificates.</a:t>
             </a:r>
           </a:p>
           <a:p>
@@ -5811,7 +7231,7 @@
                 </a:solidFill>
                 <a:latin typeface="Calibri"/>
               </a:rPr>
-              <a:t>•  Targets: CURRENT_ENERGY_RATING (ordinal A–G, primary); CURRENT_ENERGY_EFFICIENCY (1–100, secondary).</a:t>
+              <a:t>•  Targets: CURRENT_ENERGY_RATING (ordinal A-G, primary); CURRENT_ENERGY_EFFICIENCY (1-100, secondary).</a:t>
             </a:r>
           </a:p>
         </p:txBody>
@@ -5832,8 +7252,8 @@
         </p:blipFill>
         <p:spPr>
           <a:xfrm>
-            <a:off x="6858000" y="1554480"/>
-            <a:ext cx="4846320" cy="4572000"/>
+            <a:off x="6858000" y="2448587"/>
+            <a:ext cx="4846320" cy="2783786"/>
           </a:xfrm>
           <a:prstGeom prst="rect">
             <a:avLst/>
@@ -5870,7 +7290,7 @@
                 </a:solidFill>
                 <a:latin typeface="Calibri"/>
               </a:rPr>
-              <a:t>COM6003 — Oxford EPC Analysis</a:t>
+              <a:t>COM6003 • Oxford EPC Analysis</a:t>
             </a:r>
           </a:p>
         </p:txBody>
@@ -5905,7 +7325,7 @@
                 </a:solidFill>
                 <a:latin typeface="Calibri"/>
               </a:rPr>
-              <a:t>3 / 12</a:t>
+              <a:t>3 / 14</a:t>
             </a:r>
           </a:p>
         </p:txBody>
@@ -6625,7 +8045,7 @@
                 </a:solidFill>
                 <a:latin typeface="Calibri"/>
               </a:rPr>
-              <a:t>12 engineered features</a:t>
+              <a:t>19 engineered features</a:t>
             </a:r>
           </a:p>
         </p:txBody>
@@ -7169,7 +8589,7 @@
                 </a:solidFill>
                 <a:latin typeface="Calibri"/>
               </a:rPr>
-              <a:t>COM6003 — Oxford EPC Analysis</a:t>
+              <a:t>COM6003 • Oxford EPC Analysis</a:t>
             </a:r>
           </a:p>
         </p:txBody>
@@ -7204,7 +8624,7 @@
                 </a:solidFill>
                 <a:latin typeface="Calibri"/>
               </a:rPr>
-              <a:t>4 / 12</a:t>
+              <a:t>4 / 14</a:t>
             </a:r>
           </a:p>
         </p:txBody>
@@ -7300,7 +8720,7 @@
                 </a:solidFill>
                 <a:latin typeface="Calibri"/>
               </a:rPr>
-              <a:t>The single biggest pitfall — and how we avoided it</a:t>
+              <a:t>The single biggest pitfall: and how we avoided it</a:t>
             </a:r>
           </a:p>
         </p:txBody>
@@ -7374,7 +8794,7 @@
                 </a:solidFill>
                 <a:latin typeface="Calibri"/>
               </a:rPr>
-              <a:t>•  The target is *derived* from the SAP/RdSAP calculation — many columns in the CSV are *outputs* of the same engine.</a:t>
+              <a:t>•  The target is *derived* from the SAP/RdSAP calculation: many columns in the CSV are *outputs* of the same engine.</a:t>
             </a:r>
           </a:p>
         </p:txBody>
@@ -7454,7 +8874,7 @@
                 </a:solidFill>
                 <a:latin typeface="Calibri"/>
               </a:rPr>
-              <a:t>DROPPED — would leak</a:t>
+              <a:t>DROPPED: would leak</a:t>
             </a:r>
           </a:p>
         </p:txBody>
@@ -7653,7 +9073,7 @@
                 </a:solidFill>
                 <a:latin typeface="Calibri"/>
               </a:rPr>
-              <a:t>KEPT — physical reality only</a:t>
+              <a:t>KEPT: physical reality only</a:t>
             </a:r>
           </a:p>
         </p:txBody>
@@ -7807,7 +9227,7 @@
                 </a:solidFill>
                 <a:latin typeface="Calibri"/>
               </a:rPr>
-              <a:t>COM6003 — Oxford EPC Analysis</a:t>
+              <a:t>COM6003 • Oxford EPC Analysis</a:t>
             </a:r>
           </a:p>
         </p:txBody>
@@ -7842,7 +9262,7 @@
                 </a:solidFill>
                 <a:latin typeface="Calibri"/>
               </a:rPr>
-              <a:t>5 / 12</a:t>
+              <a:t>5 / 14</a:t>
             </a:r>
           </a:p>
         </p:txBody>
@@ -7938,7 +9358,7 @@
                 </a:solidFill>
                 <a:latin typeface="Calibri"/>
               </a:rPr>
-              <a:t>EDA — what we found</a:t>
+              <a:t>EDA: what we found</a:t>
             </a:r>
           </a:p>
         </p:txBody>
@@ -7994,8 +9414,8 @@
         </p:blipFill>
         <p:spPr>
           <a:xfrm>
-            <a:off x="548640" y="1554480"/>
-            <a:ext cx="5577840" cy="2468880"/>
+            <a:off x="548640" y="1554996"/>
+            <a:ext cx="5577840" cy="2467847"/>
           </a:xfrm>
           <a:prstGeom prst="rect">
             <a:avLst/>
@@ -8018,8 +9438,8 @@
         </p:blipFill>
         <p:spPr>
           <a:xfrm>
-            <a:off x="548640" y="4114800"/>
-            <a:ext cx="5577840" cy="2286000"/>
+            <a:off x="906626" y="4114800"/>
+            <a:ext cx="4861867" cy="2286000"/>
           </a:xfrm>
           <a:prstGeom prst="rect">
             <a:avLst/>
@@ -8042,8 +9462,8 @@
         </p:blipFill>
         <p:spPr>
           <a:xfrm>
-            <a:off x="6400800" y="1554480"/>
-            <a:ext cx="5394960" cy="4846320"/>
+            <a:off x="6400800" y="2582745"/>
+            <a:ext cx="5394960" cy="2789789"/>
           </a:xfrm>
           <a:prstGeom prst="rect">
             <a:avLst/>
@@ -8080,7 +9500,7 @@
                 </a:solidFill>
                 <a:latin typeface="Calibri"/>
               </a:rPr>
-              <a:t>COM6003 — Oxford EPC Analysis</a:t>
+              <a:t>COM6003 • Oxford EPC Analysis</a:t>
             </a:r>
           </a:p>
         </p:txBody>
@@ -8115,7 +9535,7 @@
                 </a:solidFill>
                 <a:latin typeface="Calibri"/>
               </a:rPr>
-              <a:t>6 / 12</a:t>
+              <a:t>6 / 14</a:t>
             </a:r>
           </a:p>
         </p:txBody>
@@ -8267,8 +9687,8 @@
         </p:blipFill>
         <p:spPr>
           <a:xfrm>
-            <a:off x="548640" y="1554480"/>
-            <a:ext cx="6858000" cy="4846320"/>
+            <a:off x="548640" y="2310917"/>
+            <a:ext cx="6858000" cy="3333446"/>
           </a:xfrm>
           <a:prstGeom prst="rect">
             <a:avLst/>
@@ -8340,7 +9760,7 @@
                 </a:solidFill>
                 <a:latin typeface="Calibri"/>
               </a:rPr>
-              <a:t>Spearman ρ — age vs SAP</a:t>
+              <a:t>Spearman ρ: age vs SAP</a:t>
             </a:r>
           </a:p>
         </p:txBody>
@@ -8375,7 +9795,7 @@
                 </a:solidFill>
                 <a:latin typeface="Calibri"/>
               </a:rPr>
-              <a:t>0.560</a:t>
+              <a:t>0.618</a:t>
             </a:r>
           </a:p>
         </p:txBody>
@@ -8410,7 +9830,7 @@
                 </a:solidFill>
                 <a:latin typeface="Calibri"/>
               </a:rPr>
-              <a:t>Spearman ρ — multi-glaze vs SAP</a:t>
+              <a:t>Spearman ρ: multi-glaze vs SAP</a:t>
             </a:r>
           </a:p>
         </p:txBody>
@@ -8445,7 +9865,7 @@
                 </a:solidFill>
                 <a:latin typeface="Calibri"/>
               </a:rPr>
-              <a:t>0.211</a:t>
+              <a:t>0.209</a:t>
             </a:r>
           </a:p>
         </p:txBody>
@@ -8480,7 +9900,7 @@
                 </a:solidFill>
                 <a:latin typeface="Calibri"/>
               </a:rPr>
-              <a:t>Cramér's V — walls vs rating</a:t>
+              <a:t>Cramér's V: walls vs rating</a:t>
             </a:r>
           </a:p>
         </p:txBody>
@@ -8550,7 +9970,7 @@
                 </a:solidFill>
                 <a:latin typeface="Calibri"/>
               </a:rPr>
-              <a:t>Cramér's V — main fuel vs rating</a:t>
+              <a:t>Cramér's V: main fuel vs rating</a:t>
             </a:r>
           </a:p>
         </p:txBody>
@@ -8585,7 +10005,7 @@
                 </a:solidFill>
                 <a:latin typeface="Calibri"/>
               </a:rPr>
-              <a:t>0.327</a:t>
+              <a:t>0.318</a:t>
             </a:r>
           </a:p>
         </p:txBody>
@@ -8620,7 +10040,7 @@
                 </a:solidFill>
                 <a:latin typeface="Calibri"/>
               </a:rPr>
-              <a:t>Cramér's V — age band vs rating</a:t>
+              <a:t>Cramér's V: age band vs rating</a:t>
             </a:r>
           </a:p>
         </p:txBody>
@@ -8655,7 +10075,7 @@
                 </a:solidFill>
                 <a:latin typeface="Calibri"/>
               </a:rPr>
-              <a:t>0.372</a:t>
+              <a:t>0.366</a:t>
             </a:r>
           </a:p>
         </p:txBody>
@@ -8690,7 +10110,7 @@
                 </a:solidFill>
                 <a:latin typeface="Calibri"/>
               </a:rPr>
-              <a:t>Cramér's V — built form vs rating</a:t>
+              <a:t>Cramér's V: built form vs rating</a:t>
             </a:r>
           </a:p>
         </p:txBody>
@@ -8725,7 +10145,7 @@
                 </a:solidFill>
                 <a:latin typeface="Calibri"/>
               </a:rPr>
-              <a:t>0.095</a:t>
+              <a:t>0.091</a:t>
             </a:r>
           </a:p>
         </p:txBody>
@@ -8760,7 +10180,7 @@
                 </a:solidFill>
                 <a:latin typeface="Calibri"/>
               </a:rPr>
-              <a:t>COM6003 — Oxford EPC Analysis</a:t>
+              <a:t>COM6003 • Oxford EPC Analysis</a:t>
             </a:r>
           </a:p>
         </p:txBody>
@@ -8795,7 +10215,7 @@
                 </a:solidFill>
                 <a:latin typeface="Calibri"/>
               </a:rPr>
-              <a:t>7 / 12</a:t>
+              <a:t>7 / 14</a:t>
             </a:r>
           </a:p>
         </p:txBody>
@@ -8926,7 +10346,7 @@
                 </a:solidFill>
                 <a:latin typeface="Calibri"/>
               </a:rPr>
-              <a:t>Quadratic Weighted Kappa — 5-fold GroupKFold (no UPRN leakage)</a:t>
+              <a:t>Quadratic Weighted Kappa: 5-fold GroupKFold (no UPRN leakage)</a:t>
             </a:r>
           </a:p>
         </p:txBody>
@@ -9739,7 +11159,7 @@
                 </a:solidFill>
                 <a:latin typeface="Calibri"/>
               </a:rPr>
-              <a:t>COM6003 — Oxford EPC Analysis</a:t>
+              <a:t>COM6003 • Oxford EPC Analysis</a:t>
             </a:r>
           </a:p>
         </p:txBody>
@@ -9774,7 +11194,7 @@
                 </a:solidFill>
                 <a:latin typeface="Calibri"/>
               </a:rPr>
-              <a:t>8 / 12</a:t>
+              <a:t>8 / 14</a:t>
             </a:r>
           </a:p>
         </p:txBody>
@@ -9870,7 +11290,7 @@
                 </a:solidFill>
                 <a:latin typeface="Calibri"/>
               </a:rPr>
-              <a:t>Champion: SapStratifiedRegressor hybrid</a:t>
+              <a:t>How the champion turns features into a band</a:t>
             </a:r>
           </a:p>
         </p:txBody>
@@ -9905,474 +11325,14 @@
                 </a:solidFill>
                 <a:latin typeface="Calibri"/>
               </a:rPr>
-              <a:t>Regression on SAP score + SAP-cohort specialist; evaluated once on inspections from 2023+. Multi-seed: 0.7714 ± 0.0019 across seeds 42/123/2026.</a:t>
-            </a:r>
-          </a:p>
-        </p:txBody>
-      </p:sp>
-      <p:sp>
-        <p:nvSpPr>
-          <p:cNvPr id="5" name="Rounded Rectangle 4"/>
-          <p:cNvSpPr/>
-          <p:nvPr/>
-        </p:nvSpPr>
-        <p:spPr>
-          <a:xfrm>
-            <a:off x="640080" y="1554480"/>
-            <a:ext cx="2606040" cy="1097280"/>
-          </a:xfrm>
-          <a:prstGeom prst="roundRect">
-            <a:avLst/>
-          </a:prstGeom>
-          <a:solidFill>
-            <a:srgbClr val="F5F7FB"/>
-          </a:solidFill>
-          <a:ln>
-            <a:solidFill>
-              <a:srgbClr val="CADCFC"/>
-            </a:solidFill>
-          </a:ln>
-        </p:spPr>
-        <p:style>
-          <a:lnRef idx="1">
-            <a:schemeClr val="accent1"/>
-          </a:lnRef>
-          <a:fillRef idx="3">
-            <a:schemeClr val="accent1"/>
-          </a:fillRef>
-          <a:effectRef idx="2">
-            <a:schemeClr val="accent1"/>
-          </a:effectRef>
-          <a:fontRef idx="minor">
-            <a:schemeClr val="lt1"/>
-          </a:fontRef>
-        </p:style>
-        <p:txBody>
-          <a:bodyPr rtlCol="0" anchor="ctr"/>
-          <a:lstStyle/>
-          <a:p>
-            <a:pPr algn="ctr"/>
-          </a:p>
-        </p:txBody>
-      </p:sp>
-      <p:sp>
-        <p:nvSpPr>
-          <p:cNvPr id="6" name="TextBox 5"/>
-          <p:cNvSpPr txBox="1"/>
-          <p:nvPr/>
-        </p:nvSpPr>
-        <p:spPr>
-          <a:xfrm>
-            <a:off x="731520" y="1627632"/>
-            <a:ext cx="2423160" cy="457200"/>
-          </a:xfrm>
-          <a:prstGeom prst="rect">
-            <a:avLst/>
-          </a:prstGeom>
-          <a:noFill/>
-        </p:spPr>
-        <p:txBody>
-          <a:bodyPr wrap="square" lIns="45720" rIns="45720" tIns="18288" bIns="18288">
-            <a:spAutoFit/>
-          </a:bodyPr>
-          <a:lstStyle/>
-          <a:p>
-            <a:pPr algn="l"/>
-            <a:r>
-              <a:rPr sz="2800" b="1" i="0">
-                <a:solidFill>
-                  <a:srgbClr val="1E2761"/>
-                </a:solidFill>
-                <a:latin typeface="Calibri"/>
-              </a:rPr>
-              <a:t>0.7696</a:t>
-            </a:r>
-          </a:p>
-        </p:txBody>
-      </p:sp>
-      <p:sp>
-        <p:nvSpPr>
-          <p:cNvPr id="7" name="TextBox 6"/>
-          <p:cNvSpPr txBox="1"/>
-          <p:nvPr/>
-        </p:nvSpPr>
-        <p:spPr>
-          <a:xfrm>
-            <a:off x="731520" y="2194560"/>
-            <a:ext cx="2423160" cy="365760"/>
-          </a:xfrm>
-          <a:prstGeom prst="rect">
-            <a:avLst/>
-          </a:prstGeom>
-          <a:noFill/>
-        </p:spPr>
-        <p:txBody>
-          <a:bodyPr wrap="square" lIns="45720" rIns="45720" tIns="18288" bIns="18288">
-            <a:spAutoFit/>
-          </a:bodyPr>
-          <a:lstStyle/>
-          <a:p>
-            <a:pPr algn="l"/>
-            <a:r>
-              <a:rPr sz="1100" b="0" i="0">
-                <a:solidFill>
-                  <a:srgbClr val="4B556B"/>
-                </a:solidFill>
-                <a:latin typeface="Calibri"/>
-              </a:rPr>
-              <a:t>Quadratic Weighted Kappa</a:t>
-            </a:r>
-          </a:p>
-        </p:txBody>
-      </p:sp>
-      <p:sp>
-        <p:nvSpPr>
-          <p:cNvPr id="8" name="Rounded Rectangle 7"/>
-          <p:cNvSpPr/>
-          <p:nvPr/>
-        </p:nvSpPr>
-        <p:spPr>
-          <a:xfrm>
-            <a:off x="3429000" y="1554480"/>
-            <a:ext cx="2606040" cy="1097280"/>
-          </a:xfrm>
-          <a:prstGeom prst="roundRect">
-            <a:avLst/>
-          </a:prstGeom>
-          <a:solidFill>
-            <a:srgbClr val="F5F7FB"/>
-          </a:solidFill>
-          <a:ln>
-            <a:solidFill>
-              <a:srgbClr val="CADCFC"/>
-            </a:solidFill>
-          </a:ln>
-        </p:spPr>
-        <p:style>
-          <a:lnRef idx="1">
-            <a:schemeClr val="accent1"/>
-          </a:lnRef>
-          <a:fillRef idx="3">
-            <a:schemeClr val="accent1"/>
-          </a:fillRef>
-          <a:effectRef idx="2">
-            <a:schemeClr val="accent1"/>
-          </a:effectRef>
-          <a:fontRef idx="minor">
-            <a:schemeClr val="lt1"/>
-          </a:fontRef>
-        </p:style>
-        <p:txBody>
-          <a:bodyPr rtlCol="0" anchor="ctr"/>
-          <a:lstStyle/>
-          <a:p>
-            <a:pPr algn="ctr"/>
-          </a:p>
-        </p:txBody>
-      </p:sp>
-      <p:sp>
-        <p:nvSpPr>
-          <p:cNvPr id="9" name="TextBox 8"/>
-          <p:cNvSpPr txBox="1"/>
-          <p:nvPr/>
-        </p:nvSpPr>
-        <p:spPr>
-          <a:xfrm>
-            <a:off x="3520440" y="1627632"/>
-            <a:ext cx="2423160" cy="457200"/>
-          </a:xfrm>
-          <a:prstGeom prst="rect">
-            <a:avLst/>
-          </a:prstGeom>
-          <a:noFill/>
-        </p:spPr>
-        <p:txBody>
-          <a:bodyPr wrap="square" lIns="45720" rIns="45720" tIns="18288" bIns="18288">
-            <a:spAutoFit/>
-          </a:bodyPr>
-          <a:lstStyle/>
-          <a:p>
-            <a:pPr algn="l"/>
-            <a:r>
-              <a:rPr sz="2800" b="1" i="0">
-                <a:solidFill>
-                  <a:srgbClr val="1E2761"/>
-                </a:solidFill>
-                <a:latin typeface="Calibri"/>
-              </a:rPr>
-              <a:t>0.578</a:t>
-            </a:r>
-          </a:p>
-        </p:txBody>
-      </p:sp>
-      <p:sp>
-        <p:nvSpPr>
-          <p:cNvPr id="10" name="TextBox 9"/>
-          <p:cNvSpPr txBox="1"/>
-          <p:nvPr/>
-        </p:nvSpPr>
-        <p:spPr>
-          <a:xfrm>
-            <a:off x="3520440" y="2194560"/>
-            <a:ext cx="2423160" cy="365760"/>
-          </a:xfrm>
-          <a:prstGeom prst="rect">
-            <a:avLst/>
-          </a:prstGeom>
-          <a:noFill/>
-        </p:spPr>
-        <p:txBody>
-          <a:bodyPr wrap="square" lIns="45720" rIns="45720" tIns="18288" bIns="18288">
-            <a:spAutoFit/>
-          </a:bodyPr>
-          <a:lstStyle/>
-          <a:p>
-            <a:pPr algn="l"/>
-            <a:r>
-              <a:rPr sz="1100" b="0" i="0">
-                <a:solidFill>
-                  <a:srgbClr val="4B556B"/>
-                </a:solidFill>
-                <a:latin typeface="Calibri"/>
-              </a:rPr>
-              <a:t>Balanced accuracy</a:t>
-            </a:r>
-          </a:p>
-        </p:txBody>
-      </p:sp>
-      <p:sp>
-        <p:nvSpPr>
-          <p:cNvPr id="11" name="Rounded Rectangle 10"/>
-          <p:cNvSpPr/>
-          <p:nvPr/>
-        </p:nvSpPr>
-        <p:spPr>
-          <a:xfrm>
-            <a:off x="6217920" y="1554480"/>
-            <a:ext cx="2606040" cy="1097280"/>
-          </a:xfrm>
-          <a:prstGeom prst="roundRect">
-            <a:avLst/>
-          </a:prstGeom>
-          <a:solidFill>
-            <a:srgbClr val="F5F7FB"/>
-          </a:solidFill>
-          <a:ln>
-            <a:solidFill>
-              <a:srgbClr val="CADCFC"/>
-            </a:solidFill>
-          </a:ln>
-        </p:spPr>
-        <p:style>
-          <a:lnRef idx="1">
-            <a:schemeClr val="accent1"/>
-          </a:lnRef>
-          <a:fillRef idx="3">
-            <a:schemeClr val="accent1"/>
-          </a:fillRef>
-          <a:effectRef idx="2">
-            <a:schemeClr val="accent1"/>
-          </a:effectRef>
-          <a:fontRef idx="minor">
-            <a:schemeClr val="lt1"/>
-          </a:fontRef>
-        </p:style>
-        <p:txBody>
-          <a:bodyPr rtlCol="0" anchor="ctr"/>
-          <a:lstStyle/>
-          <a:p>
-            <a:pPr algn="ctr"/>
-          </a:p>
-        </p:txBody>
-      </p:sp>
-      <p:sp>
-        <p:nvSpPr>
-          <p:cNvPr id="12" name="TextBox 11"/>
-          <p:cNvSpPr txBox="1"/>
-          <p:nvPr/>
-        </p:nvSpPr>
-        <p:spPr>
-          <a:xfrm>
-            <a:off x="6309360" y="1627632"/>
-            <a:ext cx="2423160" cy="457200"/>
-          </a:xfrm>
-          <a:prstGeom prst="rect">
-            <a:avLst/>
-          </a:prstGeom>
-          <a:noFill/>
-        </p:spPr>
-        <p:txBody>
-          <a:bodyPr wrap="square" lIns="45720" rIns="45720" tIns="18288" bIns="18288">
-            <a:spAutoFit/>
-          </a:bodyPr>
-          <a:lstStyle/>
-          <a:p>
-            <a:pPr algn="l"/>
-            <a:r>
-              <a:rPr sz="2800" b="1" i="0">
-                <a:solidFill>
-                  <a:srgbClr val="1E2761"/>
-                </a:solidFill>
-                <a:latin typeface="Calibri"/>
-              </a:rPr>
-              <a:t>0.561</a:t>
-            </a:r>
-          </a:p>
-        </p:txBody>
-      </p:sp>
-      <p:sp>
-        <p:nvSpPr>
-          <p:cNvPr id="13" name="TextBox 12"/>
-          <p:cNvSpPr txBox="1"/>
-          <p:nvPr/>
-        </p:nvSpPr>
-        <p:spPr>
-          <a:xfrm>
-            <a:off x="6309360" y="2194560"/>
-            <a:ext cx="2423160" cy="365760"/>
-          </a:xfrm>
-          <a:prstGeom prst="rect">
-            <a:avLst/>
-          </a:prstGeom>
-          <a:noFill/>
-        </p:spPr>
-        <p:txBody>
-          <a:bodyPr wrap="square" lIns="45720" rIns="45720" tIns="18288" bIns="18288">
-            <a:spAutoFit/>
-          </a:bodyPr>
-          <a:lstStyle/>
-          <a:p>
-            <a:pPr algn="l"/>
-            <a:r>
-              <a:rPr sz="1100" b="0" i="0">
-                <a:solidFill>
-                  <a:srgbClr val="4B556B"/>
-                </a:solidFill>
-                <a:latin typeface="Calibri"/>
-              </a:rPr>
-              <a:t>Macro-F1</a:t>
-            </a:r>
-          </a:p>
-        </p:txBody>
-      </p:sp>
-      <p:sp>
-        <p:nvSpPr>
-          <p:cNvPr id="14" name="Rounded Rectangle 13"/>
-          <p:cNvSpPr/>
-          <p:nvPr/>
-        </p:nvSpPr>
-        <p:spPr>
-          <a:xfrm>
-            <a:off x="9006839" y="1554480"/>
-            <a:ext cx="2606040" cy="1097280"/>
-          </a:xfrm>
-          <a:prstGeom prst="roundRect">
-            <a:avLst/>
-          </a:prstGeom>
-          <a:solidFill>
-            <a:srgbClr val="F5F7FB"/>
-          </a:solidFill>
-          <a:ln>
-            <a:solidFill>
-              <a:srgbClr val="CADCFC"/>
-            </a:solidFill>
-          </a:ln>
-        </p:spPr>
-        <p:style>
-          <a:lnRef idx="1">
-            <a:schemeClr val="accent1"/>
-          </a:lnRef>
-          <a:fillRef idx="3">
-            <a:schemeClr val="accent1"/>
-          </a:fillRef>
-          <a:effectRef idx="2">
-            <a:schemeClr val="accent1"/>
-          </a:effectRef>
-          <a:fontRef idx="minor">
-            <a:schemeClr val="lt1"/>
-          </a:fontRef>
-        </p:style>
-        <p:txBody>
-          <a:bodyPr rtlCol="0" anchor="ctr"/>
-          <a:lstStyle/>
-          <a:p>
-            <a:pPr algn="ctr"/>
-          </a:p>
-        </p:txBody>
-      </p:sp>
-      <p:sp>
-        <p:nvSpPr>
-          <p:cNvPr id="15" name="TextBox 14"/>
-          <p:cNvSpPr txBox="1"/>
-          <p:nvPr/>
-        </p:nvSpPr>
-        <p:spPr>
-          <a:xfrm>
-            <a:off x="9098279" y="1627632"/>
-            <a:ext cx="2423160" cy="457200"/>
-          </a:xfrm>
-          <a:prstGeom prst="rect">
-            <a:avLst/>
-          </a:prstGeom>
-          <a:noFill/>
-        </p:spPr>
-        <p:txBody>
-          <a:bodyPr wrap="square" lIns="45720" rIns="45720" tIns="18288" bIns="18288">
-            <a:spAutoFit/>
-          </a:bodyPr>
-          <a:lstStyle/>
-          <a:p>
-            <a:pPr algn="l"/>
-            <a:r>
-              <a:rPr sz="2800" b="1" i="0">
-                <a:solidFill>
-                  <a:srgbClr val="1E2761"/>
-                </a:solidFill>
-                <a:latin typeface="Calibri"/>
-              </a:rPr>
-              <a:t>4.05</a:t>
-            </a:r>
-          </a:p>
-        </p:txBody>
-      </p:sp>
-      <p:sp>
-        <p:nvSpPr>
-          <p:cNvPr id="16" name="TextBox 15"/>
-          <p:cNvSpPr txBox="1"/>
-          <p:nvPr/>
-        </p:nvSpPr>
-        <p:spPr>
-          <a:xfrm>
-            <a:off x="9098279" y="2194560"/>
-            <a:ext cx="2423160" cy="365760"/>
-          </a:xfrm>
-          <a:prstGeom prst="rect">
-            <a:avLst/>
-          </a:prstGeom>
-          <a:noFill/>
-        </p:spPr>
-        <p:txBody>
-          <a:bodyPr wrap="square" lIns="45720" rIns="45720" tIns="18288" bIns="18288">
-            <a:spAutoFit/>
-          </a:bodyPr>
-          <a:lstStyle/>
-          <a:p>
-            <a:pPr algn="l"/>
-            <a:r>
-              <a:rPr sz="1100" b="0" i="0">
-                <a:solidFill>
-                  <a:srgbClr val="4B556B"/>
-                </a:solidFill>
-                <a:latin typeface="Calibri"/>
-              </a:rPr>
-              <a:t>SAP MAE (vs ~5-pt assessor noise floor) | 97.7% within 15 SAP pts (ONS DSC national: 93%)</a:t>
+              <a:t>Regression-to-band with SAP-cohort routing</a:t>
             </a:r>
           </a:p>
         </p:txBody>
       </p:sp>
       <p:pic>
         <p:nvPicPr>
-          <p:cNvPr id="17" name="Picture 16" descr="fig_confusion.png"/>
+          <p:cNvPr id="5" name="Picture 4" descr="fig_shap_summary.png"/>
           <p:cNvPicPr>
             <a:picLocks noChangeAspect="1"/>
           </p:cNvPicPr>
@@ -10386,41 +11346,56 @@
         </p:blipFill>
         <p:spPr>
           <a:xfrm>
-            <a:off x="640080" y="2788920"/>
-            <a:ext cx="5486400" cy="3657600"/>
+            <a:off x="640080" y="1783080"/>
+            <a:ext cx="10881360" cy="3668525"/>
           </a:xfrm>
           <a:prstGeom prst="rect">
             <a:avLst/>
           </a:prstGeom>
         </p:spPr>
       </p:pic>
-      <p:pic>
-        <p:nvPicPr>
-          <p:cNvPr id="18" name="Picture 17" descr="fig_calibration_C.png"/>
-          <p:cNvPicPr>
-            <a:picLocks noChangeAspect="1"/>
-          </p:cNvPicPr>
-          <p:nvPr/>
-        </p:nvPicPr>
-        <p:blipFill>
-          <a:blip r:embed="rId3"/>
-          <a:stretch>
-            <a:fillRect/>
-          </a:stretch>
-        </p:blipFill>
-        <p:spPr>
-          <a:xfrm>
-            <a:off x="6400800" y="2788920"/>
-            <a:ext cx="5212080" cy="3657600"/>
-          </a:xfrm>
-          <a:prstGeom prst="rect">
-            <a:avLst/>
-          </a:prstGeom>
-        </p:spPr>
-      </p:pic>
-      <p:sp>
-        <p:nvSpPr>
-          <p:cNvPr id="19" name="TextBox 18"/>
+      <p:sp>
+        <p:nvSpPr>
+          <p:cNvPr id="6" name="TextBox 5"/>
+          <p:cNvSpPr txBox="1"/>
+          <p:nvPr/>
+        </p:nvSpPr>
+        <p:spPr>
+          <a:xfrm>
+            <a:off x="640080" y="5806440"/>
+            <a:ext cx="10881360" cy="731520"/>
+          </a:xfrm>
+          <a:prstGeom prst="rect">
+            <a:avLst/>
+          </a:prstGeom>
+          <a:noFill/>
+        </p:spPr>
+        <p:txBody>
+          <a:bodyPr wrap="square">
+            <a:spAutoFit/>
+          </a:bodyPr>
+          <a:lstStyle/>
+          <a:p>
+            <a:pPr algn="l">
+              <a:spcAft>
+                <a:spcPts val="600"/>
+              </a:spcAft>
+            </a:pPr>
+            <a:r>
+              <a:rPr sz="1200" i="1">
+                <a:solidFill>
+                  <a:srgbClr val="5B6472"/>
+                </a:solidFill>
+                <a:latin typeface="Calibri"/>
+              </a:rPr>
+              <a:t>EPC bands are a deterministic discretisation of the SAP score, so predicting the score and then thresholding is statistically consistent (Pedregosa et al., 2017) and supports counterfactual retrofit queries a discrete classifier cannot express.</a:t>
+            </a:r>
+          </a:p>
+        </p:txBody>
+      </p:sp>
+      <p:sp>
+        <p:nvSpPr>
+          <p:cNvPr id="7" name="TextBox 6"/>
           <p:cNvSpPr txBox="1"/>
           <p:nvPr/>
         </p:nvSpPr>
@@ -10448,14 +11423,14 @@
                 </a:solidFill>
                 <a:latin typeface="Calibri"/>
               </a:rPr>
-              <a:t>COM6003 — Oxford EPC Analysis</a:t>
-            </a:r>
-          </a:p>
-        </p:txBody>
-      </p:sp>
-      <p:sp>
-        <p:nvSpPr>
-          <p:cNvPr id="20" name="TextBox 19"/>
+              <a:t>COM6003 • Oxford EPC Analysis</a:t>
+            </a:r>
+          </a:p>
+        </p:txBody>
+      </p:sp>
+      <p:sp>
+        <p:nvSpPr>
+          <p:cNvPr id="8" name="TextBox 7"/>
           <p:cNvSpPr txBox="1"/>
           <p:nvPr/>
         </p:nvSpPr>
@@ -10483,7 +11458,7 @@
                 </a:solidFill>
                 <a:latin typeface="Calibri"/>
               </a:rPr>
-              <a:t>9 / 12</a:t>
+              <a:t>9 / 14</a:t>
             </a:r>
           </a:p>
         </p:txBody>

</xml_diff>